<commit_message>
Simplify dashboard filtering slide with Use as Filter shortcut
</commit_message>
<xml_diff>
--- a/lectures/w04-tableau-dashboard.pptx
+++ b/lectures/w04-tableau-dashboard.pptx
@@ -2,17 +2,17 @@
 <file path=ppt/presentation.xml><?xml version="1.0" encoding="utf-8"?>
 <p:presentation xmlns:p="http://schemas.openxmlformats.org/presentationml/2006/main">
   <p:sldMasterIdLst>
-    <p:sldMasterId xmlns:r="http://schemas.openxmlformats.org/officeDocument/2006/relationships" id="2147483648" r:id="R6b5ce873ac5f412b"/>
+    <p:sldMasterId xmlns:r="http://schemas.openxmlformats.org/officeDocument/2006/relationships" id="2147483648" r:id="R974146abb5b94347"/>
   </p:sldMasterIdLst>
   <p:notesMasterIdLst>
-    <p:notesMasterId xmlns:r="http://schemas.openxmlformats.org/officeDocument/2006/relationships" r:id="R55020a8003d94f46"/>
+    <p:notesMasterId xmlns:r="http://schemas.openxmlformats.org/officeDocument/2006/relationships" r:id="R0b24f63238a145f2"/>
   </p:notesMasterIdLst>
   <p:sldIdLst>
-    <p:sldId xmlns:r="http://schemas.openxmlformats.org/officeDocument/2006/relationships" id="256" r:id="R0ad41581167f4baa"/>
-    <p:sldId xmlns:r="http://schemas.openxmlformats.org/officeDocument/2006/relationships" id="257" r:id="Rce1e9a9194164481"/>
-    <p:sldId xmlns:r="http://schemas.openxmlformats.org/officeDocument/2006/relationships" id="258" r:id="R7a608076e21e4fff"/>
-    <p:sldId xmlns:r="http://schemas.openxmlformats.org/officeDocument/2006/relationships" id="259" r:id="R3131e20005cc4ea9"/>
-    <p:sldId xmlns:r="http://schemas.openxmlformats.org/officeDocument/2006/relationships" id="260" r:id="R06b32826c5d748a4"/>
+    <p:sldId xmlns:r="http://schemas.openxmlformats.org/officeDocument/2006/relationships" id="256" r:id="Ra3f4c2a980b44141"/>
+    <p:sldId xmlns:r="http://schemas.openxmlformats.org/officeDocument/2006/relationships" id="257" r:id="R13ffc787e0da4657"/>
+    <p:sldId xmlns:r="http://schemas.openxmlformats.org/officeDocument/2006/relationships" id="258" r:id="Ree8287eded2c46ba"/>
+    <p:sldId xmlns:r="http://schemas.openxmlformats.org/officeDocument/2006/relationships" id="259" r:id="R05bf4635bece493b"/>
+    <p:sldId xmlns:r="http://schemas.openxmlformats.org/officeDocument/2006/relationships" id="260" r:id="R181eaf8d46754c53"/>
   </p:sldIdLst>
   <p:sldSz cx="12192000" cy="6858000"/>
   <p:notesSz cx="6858000" cy="9144000"/>
@@ -741,7 +741,12 @@
           <a:lstStyle xmlns:a="http://schemas.openxmlformats.org/drawingml/2006/main"/>
           <a:p xmlns:a="http://schemas.openxmlformats.org/drawingml/2006/main">
             <a:r>
-              <a:t>Create a Filter action. Source sheet World. Run action on Select; optionally Single-select only. Target sheets Life History and GDP History. Choose Selected Fields, then map Country to Country using the same data source. Do not use All Fields: it can pass Year=2020 and region along with Country and destroy the time series. Clearing selection: Show all values. If a generated Use as Filter action already exists, edit or remove it rather than leaving a conflicting second action. In this example the top right chart shows Japan and bottom right India, as two successive selection outcomes; the action updates both histories in the actual dashboard. Test Japan, India, then click empty space to clear. Finally publish the dashboard on Tableau Public and check the shared view in a signed-out browser. UI labels may vary by version/language.</a:t>
+              <a:t>On the dashboard, select the World sheet to reveal its toolbar. Click the funnel icon, Use as Filter. The sheet menu also offers Use as Filter. Click Japan or India in the chart to filter the other sheets. Tableau creates a generated Filter action. In Dashboard &gt; Actions, edit that existing generated action rather than adding a second one. Confirm source World, Run on Select, target sheets Life History and GDP History. Under Target Filters choose Selected Fields and map Country to Country only. Do not pass Year=2020 to the histories. Set clearing selection to Show all values. Test that Japan and India each show 1960-2020, then click empty space to reset. The two right-hand charts illustrate successive country selections, not two different target sheets.</a:t>
+            </a:r>
+          </a:p>
+          <a:p xmlns:a="http://schemas.openxmlformats.org/drawingml/2006/main">
+            <a:r>
+              <a:t>https://help.tableau.com/current/pro/desktop/en-us/actions_filter.htm</a:t>
             </a:r>
           </a:p>
           <a:p xmlns:a="http://schemas.openxmlformats.org/drawingml/2006/main">
@@ -913,7 +918,7 @@
           <p:cNvPr id="3" name="Title">
             <a:extLst xmlns:a="http://schemas.openxmlformats.org/drawingml/2006/main">
               <a:ext uri="{FF2B5EF4-FFF2-40B4-BE49-F238E27FC236}">
-                <a16:creationId xmlns:a16="http://schemas.microsoft.com/office/drawing/2014/main" id="{0D8DF9FD-38A9-419E-A485-79B495A98DD1}"/>
+                <a16:creationId xmlns:a16="http://schemas.microsoft.com/office/drawing/2014/main" id="{64D5C3A6-BDD0-4F20-A376-AECF000603C2}"/>
               </a:ext>
             </a:extLst>
           </p:cNvPr>
@@ -1070,7 +1075,7 @@
           <p:cNvPr id="2" name="Subtitle">
             <a:extLst xmlns:a="http://schemas.openxmlformats.org/drawingml/2006/main">
               <a:ext uri="{FF2B5EF4-FFF2-40B4-BE49-F238E27FC236}">
-                <a16:creationId xmlns:a16="http://schemas.microsoft.com/office/drawing/2014/main" id="{AB1D4785-0599-463B-BDBA-EAA0B52A417A}"/>
+                <a16:creationId xmlns:a16="http://schemas.microsoft.com/office/drawing/2014/main" id="{BB4AEBE0-A2C2-4147-9144-C4E2323F50EA}"/>
               </a:ext>
             </a:extLst>
           </p:cNvPr>
@@ -1244,7 +1249,7 @@
           <p:cNvPr id="2" name="Section title">
             <a:extLst xmlns:a="http://schemas.openxmlformats.org/drawingml/2006/main">
               <a:ext uri="{FF2B5EF4-FFF2-40B4-BE49-F238E27FC236}">
-                <a16:creationId xmlns:a16="http://schemas.microsoft.com/office/drawing/2014/main" id="{57928535-44E9-446A-B536-1ABEA75D0069}"/>
+                <a16:creationId xmlns:a16="http://schemas.microsoft.com/office/drawing/2014/main" id="{0E670F62-3D9C-4712-BC25-044568A3CB1F}"/>
               </a:ext>
             </a:extLst>
           </p:cNvPr>
@@ -1418,7 +1423,7 @@
           <p:cNvPr id="3" name="Title">
             <a:extLst xmlns:a="http://schemas.openxmlformats.org/drawingml/2006/main">
               <a:ext uri="{FF2B5EF4-FFF2-40B4-BE49-F238E27FC236}">
-                <a16:creationId xmlns:a16="http://schemas.microsoft.com/office/drawing/2014/main" id="{D179F0E9-41C4-421E-B6E0-7C315AD9C4DE}"/>
+                <a16:creationId xmlns:a16="http://schemas.microsoft.com/office/drawing/2014/main" id="{7274B51F-E685-47DC-A9F1-B1F88F539C4A}"/>
               </a:ext>
             </a:extLst>
           </p:cNvPr>
@@ -1575,7 +1580,7 @@
           <p:cNvPr id="2" name="Body">
             <a:extLst xmlns:a="http://schemas.openxmlformats.org/drawingml/2006/main">
               <a:ext uri="{FF2B5EF4-FFF2-40B4-BE49-F238E27FC236}">
-                <a16:creationId xmlns:a16="http://schemas.microsoft.com/office/drawing/2014/main" id="{828D7E05-F928-49CC-A5B5-C8716B73A46B}"/>
+                <a16:creationId xmlns:a16="http://schemas.microsoft.com/office/drawing/2014/main" id="{744503B7-0BB0-43F3-B8A4-3DF562B3854C}"/>
               </a:ext>
             </a:extLst>
           </p:cNvPr>
@@ -1749,7 +1754,7 @@
           <p:cNvPr id="4" name="Title">
             <a:extLst xmlns:a="http://schemas.openxmlformats.org/drawingml/2006/main">
               <a:ext uri="{FF2B5EF4-FFF2-40B4-BE49-F238E27FC236}">
-                <a16:creationId xmlns:a16="http://schemas.microsoft.com/office/drawing/2014/main" id="{94BA8C28-6BB3-471C-8695-C43A9B08C391}"/>
+                <a16:creationId xmlns:a16="http://schemas.microsoft.com/office/drawing/2014/main" id="{0C252B36-77FF-4F5B-B463-6E628E1796C3}"/>
               </a:ext>
             </a:extLst>
           </p:cNvPr>
@@ -1906,7 +1911,7 @@
           <p:cNvPr id="2" name="Left column">
             <a:extLst xmlns:a="http://schemas.openxmlformats.org/drawingml/2006/main">
               <a:ext uri="{FF2B5EF4-FFF2-40B4-BE49-F238E27FC236}">
-                <a16:creationId xmlns:a16="http://schemas.microsoft.com/office/drawing/2014/main" id="{91CAF296-28DD-4C23-B776-6386CDEF06E1}"/>
+                <a16:creationId xmlns:a16="http://schemas.microsoft.com/office/drawing/2014/main" id="{87236022-97E1-4C9F-9394-212DA04FCB08}"/>
               </a:ext>
             </a:extLst>
           </p:cNvPr>
@@ -2063,7 +2068,7 @@
           <p:cNvPr id="3" name="Right column">
             <a:extLst xmlns:a="http://schemas.openxmlformats.org/drawingml/2006/main">
               <a:ext uri="{FF2B5EF4-FFF2-40B4-BE49-F238E27FC236}">
-                <a16:creationId xmlns:a16="http://schemas.microsoft.com/office/drawing/2014/main" id="{45718407-0B03-4D4E-90B1-5A6C0B8CCAB6}"/>
+                <a16:creationId xmlns:a16="http://schemas.microsoft.com/office/drawing/2014/main" id="{BB0723CA-70EA-40DF-A969-813A390FAF5B}"/>
               </a:ext>
             </a:extLst>
           </p:cNvPr>
@@ -2237,7 +2242,7 @@
           <p:cNvPr id="3" name="Title">
             <a:extLst xmlns:a="http://schemas.openxmlformats.org/drawingml/2006/main">
               <a:ext uri="{FF2B5EF4-FFF2-40B4-BE49-F238E27FC236}">
-                <a16:creationId xmlns:a16="http://schemas.microsoft.com/office/drawing/2014/main" id="{2874E402-9DB7-4255-89A9-D7190266403D}"/>
+                <a16:creationId xmlns:a16="http://schemas.microsoft.com/office/drawing/2014/main" id="{51175EE1-8EEB-4831-97C0-23845FFCB1C2}"/>
               </a:ext>
             </a:extLst>
           </p:cNvPr>
@@ -2394,7 +2399,7 @@
           <p:cNvPr id="2" name="Left column">
             <a:extLst xmlns:a="http://schemas.openxmlformats.org/drawingml/2006/main">
               <a:ext uri="{FF2B5EF4-FFF2-40B4-BE49-F238E27FC236}">
-                <a16:creationId xmlns:a16="http://schemas.microsoft.com/office/drawing/2014/main" id="{E1B8B523-5A9E-4B75-ABC4-A50D488071CA}"/>
+                <a16:creationId xmlns:a16="http://schemas.microsoft.com/office/drawing/2014/main" id="{67C6FD5D-EA2F-4C4A-B235-D410B87D4CF1}"/>
               </a:ext>
             </a:extLst>
           </p:cNvPr>
@@ -2589,12 +2594,12 @@
   </p:cSld>
   <p:clrMap bg1="lt1" tx1="dk1" bg2="lt2" tx2="dk2" accent1="accent1" accent2="accent2" accent3="accent3" accent4="accent4" accent5="accent5" accent6="accent6" hlink="hlink" folHlink="folHlink"/>
   <p:sldLayoutIdLst>
-    <p:sldLayoutId xmlns:r="http://schemas.openxmlformats.org/officeDocument/2006/relationships" id="2147483649" r:id="R7e49addc1ec940b9"/>
-    <p:sldLayoutId xmlns:r="http://schemas.openxmlformats.org/officeDocument/2006/relationships" id="2147483650" r:id="R9032ab64745f4b9f"/>
-    <p:sldLayoutId xmlns:r="http://schemas.openxmlformats.org/officeDocument/2006/relationships" id="2147483651" r:id="Re97901e19e00493b"/>
-    <p:sldLayoutId xmlns:r="http://schemas.openxmlformats.org/officeDocument/2006/relationships" id="2147483652" r:id="Rfa105abbde9a4700"/>
-    <p:sldLayoutId xmlns:r="http://schemas.openxmlformats.org/officeDocument/2006/relationships" id="2147483653" r:id="Rc9a4834d9dc243e9"/>
-    <p:sldLayoutId xmlns:r="http://schemas.openxmlformats.org/officeDocument/2006/relationships" id="2147483654" r:id="R1dfc1a2cedfb4ae1"/>
+    <p:sldLayoutId xmlns:r="http://schemas.openxmlformats.org/officeDocument/2006/relationships" id="2147483649" r:id="Reab03b29f7924fd7"/>
+    <p:sldLayoutId xmlns:r="http://schemas.openxmlformats.org/officeDocument/2006/relationships" id="2147483650" r:id="Rdaeafe35fd2d47a3"/>
+    <p:sldLayoutId xmlns:r="http://schemas.openxmlformats.org/officeDocument/2006/relationships" id="2147483651" r:id="Rd6b04119da344616"/>
+    <p:sldLayoutId xmlns:r="http://schemas.openxmlformats.org/officeDocument/2006/relationships" id="2147483652" r:id="R461c56dec2b740db"/>
+    <p:sldLayoutId xmlns:r="http://schemas.openxmlformats.org/officeDocument/2006/relationships" id="2147483653" r:id="R34b24e82bdda4861"/>
+    <p:sldLayoutId xmlns:r="http://schemas.openxmlformats.org/officeDocument/2006/relationships" id="2147483654" r:id="R8ce254d3aed548bc"/>
   </p:sldLayoutIdLst>
   <p:txStyles>
     <p:titleStyle>
@@ -7659,7 +7664,7 @@
           <p:cNvPr id="15" name="">
             <a:extLst xmlns:a="http://schemas.openxmlformats.org/drawingml/2006/main">
               <a:ext uri="{FF2B5EF4-FFF2-40B4-BE49-F238E27FC236}">
-                <a16:creationId xmlns:a16="http://schemas.microsoft.com/office/drawing/2014/main" id="{61BFA0A1-D077-4F1A-A32D-1C24031E6819}"/>
+                <a16:creationId xmlns:a16="http://schemas.microsoft.com/office/drawing/2014/main" id="{9249D605-71B9-4C62-B4CF-A9AADE0D2F33}"/>
               </a:ext>
             </a:extLst>
           </p:cNvPr>
@@ -7725,7 +7730,7 @@
           <p:cNvPr id="2" name="">
             <a:extLst xmlns:a="http://schemas.openxmlformats.org/drawingml/2006/main">
               <a:ext uri="{FF2B5EF4-FFF2-40B4-BE49-F238E27FC236}">
-                <a16:creationId xmlns:a16="http://schemas.microsoft.com/office/drawing/2014/main" id="{6CBD55A9-C61C-42ED-81B8-03854C85E98D}"/>
+                <a16:creationId xmlns:a16="http://schemas.microsoft.com/office/drawing/2014/main" id="{2D39E979-7536-4CEB-BB3D-C645E489BE3E}"/>
               </a:ext>
             </a:extLst>
           </p:cNvPr>
@@ -7791,7 +7796,7 @@
           <p:cNvPr id="3" name="">
             <a:extLst xmlns:a="http://schemas.openxmlformats.org/drawingml/2006/main">
               <a:ext uri="{FF2B5EF4-FFF2-40B4-BE49-F238E27FC236}">
-                <a16:creationId xmlns:a16="http://schemas.microsoft.com/office/drawing/2014/main" id="{6B4D59E4-797A-45B5-AB52-05867B464617}"/>
+                <a16:creationId xmlns:a16="http://schemas.microsoft.com/office/drawing/2014/main" id="{6349A6F6-C46D-44CE-8137-BF01CB716AD1}"/>
               </a:ext>
             </a:extLst>
           </p:cNvPr>
@@ -7857,7 +7862,7 @@
           <p:cNvPr id="4" name="">
             <a:extLst xmlns:a="http://schemas.openxmlformats.org/drawingml/2006/main">
               <a:ext uri="{FF2B5EF4-FFF2-40B4-BE49-F238E27FC236}">
-                <a16:creationId xmlns:a16="http://schemas.microsoft.com/office/drawing/2014/main" id="{E3781B5F-C6F7-4F79-BB2C-1D09B691F87F}"/>
+                <a16:creationId xmlns:a16="http://schemas.microsoft.com/office/drawing/2014/main" id="{6D4C1F8E-C0D8-4D2E-99A1-6F236A49E4F4}"/>
               </a:ext>
             </a:extLst>
           </p:cNvPr>
@@ -7923,7 +7928,7 @@
           <p:cNvPr id="5" name="Chart">
             <a:extLst xmlns:a="http://schemas.openxmlformats.org/drawingml/2006/main">
               <a:ext uri="{FF2B5EF4-FFF2-40B4-BE49-F238E27FC236}">
-                <a16:creationId xmlns:a16="http://schemas.microsoft.com/office/drawing/2014/main" id="{0BB5248E-CF3C-465D-BD76-AA61EECD7189}"/>
+                <a16:creationId xmlns:a16="http://schemas.microsoft.com/office/drawing/2014/main" id="{E4DDA5A4-1BF0-437C-8CC0-EB39E8D0A82E}"/>
               </a:ext>
             </a:extLst>
           </p:cNvPr>
@@ -7936,7 +7941,7 @@
         </p:xfrm>
         <a:graphic xmlns:a="http://schemas.openxmlformats.org/drawingml/2006/main">
           <a:graphicData uri="http://schemas.openxmlformats.org/drawingml/2006/chart">
-            <c:chart xmlns:r="http://schemas.openxmlformats.org/officeDocument/2006/relationships" xmlns:c="http://schemas.openxmlformats.org/drawingml/2006/chart" r:id="R19d51970d5294c12"/>
+            <c:chart xmlns:r="http://schemas.openxmlformats.org/officeDocument/2006/relationships" xmlns:c="http://schemas.openxmlformats.org/drawingml/2006/chart" r:id="R8589705092bf4b46"/>
           </a:graphicData>
         </a:graphic>
       </p:graphicFrame>
@@ -7945,7 +7950,7 @@
           <p:cNvPr id="6" name="">
             <a:extLst xmlns:a="http://schemas.openxmlformats.org/drawingml/2006/main">
               <a:ext uri="{FF2B5EF4-FFF2-40B4-BE49-F238E27FC236}">
-                <a16:creationId xmlns:a16="http://schemas.microsoft.com/office/drawing/2014/main" id="{AE98E9F1-8DCA-4A51-A56F-3C45CEB978A5}"/>
+                <a16:creationId xmlns:a16="http://schemas.microsoft.com/office/drawing/2014/main" id="{E5A5731C-D0CE-403A-85C8-C430219DDC52}"/>
               </a:ext>
             </a:extLst>
           </p:cNvPr>
@@ -8011,7 +8016,7 @@
           <p:cNvPr id="7" name="Chart">
             <a:extLst xmlns:a="http://schemas.openxmlformats.org/drawingml/2006/main">
               <a:ext uri="{FF2B5EF4-FFF2-40B4-BE49-F238E27FC236}">
-                <a16:creationId xmlns:a16="http://schemas.microsoft.com/office/drawing/2014/main" id="{66FAC151-74A0-4845-AEC9-AD7B1C63BEFC}"/>
+                <a16:creationId xmlns:a16="http://schemas.microsoft.com/office/drawing/2014/main" id="{5B22A62D-B6A8-454B-94E8-A7FDD60C3A45}"/>
               </a:ext>
             </a:extLst>
           </p:cNvPr>
@@ -8024,7 +8029,7 @@
         </p:xfrm>
         <a:graphic xmlns:a="http://schemas.openxmlformats.org/drawingml/2006/main">
           <a:graphicData uri="http://schemas.openxmlformats.org/drawingml/2006/chart">
-            <c:chart xmlns:r="http://schemas.openxmlformats.org/officeDocument/2006/relationships" xmlns:c="http://schemas.openxmlformats.org/drawingml/2006/chart" r:id="R8c6016c3d9344693"/>
+            <c:chart xmlns:r="http://schemas.openxmlformats.org/officeDocument/2006/relationships" xmlns:c="http://schemas.openxmlformats.org/drawingml/2006/chart" r:id="Ra43629a6f380478f"/>
           </a:graphicData>
         </a:graphic>
       </p:graphicFrame>
@@ -8033,7 +8038,7 @@
           <p:cNvPr id="8" name="">
             <a:extLst xmlns:a="http://schemas.openxmlformats.org/drawingml/2006/main">
               <a:ext uri="{FF2B5EF4-FFF2-40B4-BE49-F238E27FC236}">
-                <a16:creationId xmlns:a16="http://schemas.microsoft.com/office/drawing/2014/main" id="{E67E9520-6B7D-49BB-9CED-12D0D9FDCB8F}"/>
+                <a16:creationId xmlns:a16="http://schemas.microsoft.com/office/drawing/2014/main" id="{1C89F9F8-F1D6-44EE-AE01-BCCEEDA37D2E}"/>
               </a:ext>
             </a:extLst>
           </p:cNvPr>
@@ -8099,7 +8104,7 @@
           <p:cNvPr id="9" name="Chart">
             <a:extLst xmlns:a="http://schemas.openxmlformats.org/drawingml/2006/main">
               <a:ext uri="{FF2B5EF4-FFF2-40B4-BE49-F238E27FC236}">
-                <a16:creationId xmlns:a16="http://schemas.microsoft.com/office/drawing/2014/main" id="{44404043-6BAA-481C-B48A-AA640E850268}"/>
+                <a16:creationId xmlns:a16="http://schemas.microsoft.com/office/drawing/2014/main" id="{3B19A254-7CC8-49D9-8258-A3F991B4A239}"/>
               </a:ext>
             </a:extLst>
           </p:cNvPr>
@@ -8112,7 +8117,7 @@
         </p:xfrm>
         <a:graphic xmlns:a="http://schemas.openxmlformats.org/drawingml/2006/main">
           <a:graphicData uri="http://schemas.openxmlformats.org/drawingml/2006/chart">
-            <c:chart xmlns:r="http://schemas.openxmlformats.org/officeDocument/2006/relationships" xmlns:c="http://schemas.openxmlformats.org/drawingml/2006/chart" r:id="R62b79268055d4967"/>
+            <c:chart xmlns:r="http://schemas.openxmlformats.org/officeDocument/2006/relationships" xmlns:c="http://schemas.openxmlformats.org/drawingml/2006/chart" r:id="R0a3f7415c12e4ffd"/>
           </a:graphicData>
         </a:graphic>
       </p:graphicFrame>
@@ -8121,7 +8126,7 @@
           <p:cNvPr id="10" name="">
             <a:extLst xmlns:a="http://schemas.openxmlformats.org/drawingml/2006/main">
               <a:ext uri="{FF2B5EF4-FFF2-40B4-BE49-F238E27FC236}">
-                <a16:creationId xmlns:a16="http://schemas.microsoft.com/office/drawing/2014/main" id="{83617047-6587-42B2-ACCC-69E96F87942B}"/>
+                <a16:creationId xmlns:a16="http://schemas.microsoft.com/office/drawing/2014/main" id="{5112435A-3FB6-457E-85E6-E77D2B99A39D}"/>
               </a:ext>
             </a:extLst>
           </p:cNvPr>
@@ -8187,7 +8192,7 @@
           <p:cNvPr id="11" name="">
             <a:extLst xmlns:a="http://schemas.openxmlformats.org/drawingml/2006/main">
               <a:ext uri="{FF2B5EF4-FFF2-40B4-BE49-F238E27FC236}">
-                <a16:creationId xmlns:a16="http://schemas.microsoft.com/office/drawing/2014/main" id="{B95937BA-EF37-4619-8FC8-EEE4F075F8DF}"/>
+                <a16:creationId xmlns:a16="http://schemas.microsoft.com/office/drawing/2014/main" id="{3F75F268-C625-4B9B-BEB9-74AB1FD44AC7}"/>
               </a:ext>
             </a:extLst>
           </p:cNvPr>
@@ -8253,7 +8258,7 @@
           <p:cNvPr id="12" name="">
             <a:extLst xmlns:a="http://schemas.openxmlformats.org/drawingml/2006/main">
               <a:ext uri="{FF2B5EF4-FFF2-40B4-BE49-F238E27FC236}">
-                <a16:creationId xmlns:a16="http://schemas.microsoft.com/office/drawing/2014/main" id="{D17AAC30-D73B-4C08-8E41-13AE3BAB50FC}"/>
+                <a16:creationId xmlns:a16="http://schemas.microsoft.com/office/drawing/2014/main" id="{0C87B709-E85E-4F9B-87F2-B56FF91B6AF7}"/>
               </a:ext>
             </a:extLst>
           </p:cNvPr>
@@ -8319,7 +8324,7 @@
           <p:cNvPr id="13" name="">
             <a:extLst xmlns:a="http://schemas.openxmlformats.org/drawingml/2006/main">
               <a:ext uri="{FF2B5EF4-FFF2-40B4-BE49-F238E27FC236}">
-                <a16:creationId xmlns:a16="http://schemas.microsoft.com/office/drawing/2014/main" id="{EBB39EEB-62DE-4489-90F6-D9E341F88C79}"/>
+                <a16:creationId xmlns:a16="http://schemas.microsoft.com/office/drawing/2014/main" id="{EF752CDD-3B75-4131-B0C8-AEE01848B420}"/>
               </a:ext>
             </a:extLst>
           </p:cNvPr>
@@ -8385,7 +8390,7 @@
           <p:cNvPr id="14" name="">
             <a:extLst xmlns:a="http://schemas.openxmlformats.org/drawingml/2006/main">
               <a:ext uri="{FF2B5EF4-FFF2-40B4-BE49-F238E27FC236}">
-                <a16:creationId xmlns:a16="http://schemas.microsoft.com/office/drawing/2014/main" id="{B138B716-E2B0-402D-8C49-2FBFEB6D0F9C}"/>
+                <a16:creationId xmlns:a16="http://schemas.microsoft.com/office/drawing/2014/main" id="{A7F11816-B373-480F-9A21-CEE15BCCC392}"/>
               </a:ext>
             </a:extLst>
           </p:cNvPr>
@@ -8449,7 +8454,7 @@
     </p:spTree>
     <p:extLst>
       <p:ext uri="{BB962C8B-B14F-4D97-AF65-F5344CB8AC3E}">
-        <p14:creationId xmlns:p14="http://schemas.microsoft.com/office/powerpoint/2010/main" val="1756363086"/>
+        <p14:creationId xmlns:p14="http://schemas.microsoft.com/office/powerpoint/2010/main" val="554577772"/>
       </p:ext>
     </p:extLst>
   </p:cSld>
@@ -8480,7 +8485,7 @@
           <p:cNvPr id="46" name="">
             <a:extLst xmlns:a="http://schemas.openxmlformats.org/drawingml/2006/main">
               <a:ext uri="{FF2B5EF4-FFF2-40B4-BE49-F238E27FC236}">
-                <a16:creationId xmlns:a16="http://schemas.microsoft.com/office/drawing/2014/main" id="{268E2BD2-3AFB-4402-B859-C4D83E8ABDD4}"/>
+                <a16:creationId xmlns:a16="http://schemas.microsoft.com/office/drawing/2014/main" id="{064FFDBC-E867-4D0F-BDB8-F811DE900EED}"/>
               </a:ext>
             </a:extLst>
           </p:cNvPr>
@@ -8546,7 +8551,7 @@
           <p:cNvPr id="2" name="">
             <a:extLst xmlns:a="http://schemas.openxmlformats.org/drawingml/2006/main">
               <a:ext uri="{FF2B5EF4-FFF2-40B4-BE49-F238E27FC236}">
-                <a16:creationId xmlns:a16="http://schemas.microsoft.com/office/drawing/2014/main" id="{D44EB842-301D-4603-8951-1CFF47EF0A46}"/>
+                <a16:creationId xmlns:a16="http://schemas.microsoft.com/office/drawing/2014/main" id="{2801327F-4278-40C0-B047-1D6B9DE02F6C}"/>
               </a:ext>
             </a:extLst>
           </p:cNvPr>
@@ -8612,7 +8617,7 @@
           <p:cNvPr id="3" name="">
             <a:extLst xmlns:a="http://schemas.openxmlformats.org/drawingml/2006/main">
               <a:ext uri="{FF2B5EF4-FFF2-40B4-BE49-F238E27FC236}">
-                <a16:creationId xmlns:a16="http://schemas.microsoft.com/office/drawing/2014/main" id="{CF2A9DCC-BA4D-4967-841A-494DDC1D9CB9}"/>
+                <a16:creationId xmlns:a16="http://schemas.microsoft.com/office/drawing/2014/main" id="{534862A8-963A-43E0-9658-A2BBE09A5FD6}"/>
               </a:ext>
             </a:extLst>
           </p:cNvPr>
@@ -8678,7 +8683,7 @@
           <p:cNvPr id="4" name="">
             <a:extLst xmlns:a="http://schemas.openxmlformats.org/drawingml/2006/main">
               <a:ext uri="{FF2B5EF4-FFF2-40B4-BE49-F238E27FC236}">
-                <a16:creationId xmlns:a16="http://schemas.microsoft.com/office/drawing/2014/main" id="{44FFCF1A-F0B2-4F37-934E-16C2F5FBB28F}"/>
+                <a16:creationId xmlns:a16="http://schemas.microsoft.com/office/drawing/2014/main" id="{41CF9541-4321-42FC-956D-CD799FBBD3F0}"/>
               </a:ext>
             </a:extLst>
           </p:cNvPr>
@@ -8744,7 +8749,7 @@
           <p:cNvPr id="5" name="">
             <a:extLst xmlns:a="http://schemas.openxmlformats.org/drawingml/2006/main">
               <a:ext uri="{FF2B5EF4-FFF2-40B4-BE49-F238E27FC236}">
-                <a16:creationId xmlns:a16="http://schemas.microsoft.com/office/drawing/2014/main" id="{820DBAB9-0FCE-452C-9843-9FF61D724D69}"/>
+                <a16:creationId xmlns:a16="http://schemas.microsoft.com/office/drawing/2014/main" id="{95C51C02-A617-4F9D-A8CE-07B25D9DFA41}"/>
               </a:ext>
             </a:extLst>
           </p:cNvPr>
@@ -8774,7 +8779,7 @@
           <p:cNvPr id="6" name="">
             <a:extLst xmlns:a="http://schemas.openxmlformats.org/drawingml/2006/main">
               <a:ext uri="{FF2B5EF4-FFF2-40B4-BE49-F238E27FC236}">
-                <a16:creationId xmlns:a16="http://schemas.microsoft.com/office/drawing/2014/main" id="{8216499D-1740-4DD2-AA13-E7B791B88AE7}"/>
+                <a16:creationId xmlns:a16="http://schemas.microsoft.com/office/drawing/2014/main" id="{585AC045-2A38-4658-9152-7B02BF552D9C}"/>
               </a:ext>
             </a:extLst>
           </p:cNvPr>
@@ -8840,7 +8845,7 @@
           <p:cNvPr id="7" name="">
             <a:extLst xmlns:a="http://schemas.openxmlformats.org/drawingml/2006/main">
               <a:ext uri="{FF2B5EF4-FFF2-40B4-BE49-F238E27FC236}">
-                <a16:creationId xmlns:a16="http://schemas.microsoft.com/office/drawing/2014/main" id="{A6B8BBE7-1A60-488F-9D90-77DC2176A6EC}"/>
+                <a16:creationId xmlns:a16="http://schemas.microsoft.com/office/drawing/2014/main" id="{7529F99E-28A8-4999-BF26-CCB965D445D2}"/>
               </a:ext>
             </a:extLst>
           </p:cNvPr>
@@ -8906,7 +8911,7 @@
           <p:cNvPr id="8" name="">
             <a:extLst xmlns:a="http://schemas.openxmlformats.org/drawingml/2006/main">
               <a:ext uri="{FF2B5EF4-FFF2-40B4-BE49-F238E27FC236}">
-                <a16:creationId xmlns:a16="http://schemas.microsoft.com/office/drawing/2014/main" id="{4E3240EA-2942-4820-99C0-63272A4653B1}"/>
+                <a16:creationId xmlns:a16="http://schemas.microsoft.com/office/drawing/2014/main" id="{C3B2495C-1658-4A06-9D10-455CBE361CE1}"/>
               </a:ext>
             </a:extLst>
           </p:cNvPr>
@@ -8936,7 +8941,7 @@
           <p:cNvPr id="9" name="">
             <a:extLst xmlns:a="http://schemas.openxmlformats.org/drawingml/2006/main">
               <a:ext uri="{FF2B5EF4-FFF2-40B4-BE49-F238E27FC236}">
-                <a16:creationId xmlns:a16="http://schemas.microsoft.com/office/drawing/2014/main" id="{3CAE6F61-1612-4CC8-B95D-1959279F207D}"/>
+                <a16:creationId xmlns:a16="http://schemas.microsoft.com/office/drawing/2014/main" id="{360D085B-2023-4537-B04E-05BA05E8673E}"/>
               </a:ext>
             </a:extLst>
           </p:cNvPr>
@@ -9002,7 +9007,7 @@
           <p:cNvPr id="10" name="">
             <a:extLst xmlns:a="http://schemas.openxmlformats.org/drawingml/2006/main">
               <a:ext uri="{FF2B5EF4-FFF2-40B4-BE49-F238E27FC236}">
-                <a16:creationId xmlns:a16="http://schemas.microsoft.com/office/drawing/2014/main" id="{7204A9D2-E6AC-4798-8C59-A3B3557E5F3D}"/>
+                <a16:creationId xmlns:a16="http://schemas.microsoft.com/office/drawing/2014/main" id="{D8175B9E-1DAD-4EEC-92B7-71968E3B30D9}"/>
               </a:ext>
             </a:extLst>
           </p:cNvPr>
@@ -9068,7 +9073,7 @@
           <p:cNvPr id="11" name="">
             <a:extLst xmlns:a="http://schemas.openxmlformats.org/drawingml/2006/main">
               <a:ext uri="{FF2B5EF4-FFF2-40B4-BE49-F238E27FC236}">
-                <a16:creationId xmlns:a16="http://schemas.microsoft.com/office/drawing/2014/main" id="{91DE13C7-E3E7-40E3-9B0C-64E66B264FB6}"/>
+                <a16:creationId xmlns:a16="http://schemas.microsoft.com/office/drawing/2014/main" id="{CD771732-8B7E-40F4-8BD4-A62604FE1DDC}"/>
               </a:ext>
             </a:extLst>
           </p:cNvPr>
@@ -9098,7 +9103,7 @@
           <p:cNvPr id="12" name="">
             <a:extLst xmlns:a="http://schemas.openxmlformats.org/drawingml/2006/main">
               <a:ext uri="{FF2B5EF4-FFF2-40B4-BE49-F238E27FC236}">
-                <a16:creationId xmlns:a16="http://schemas.microsoft.com/office/drawing/2014/main" id="{4273804E-7F66-4C6A-9791-964BA33C6A60}"/>
+                <a16:creationId xmlns:a16="http://schemas.microsoft.com/office/drawing/2014/main" id="{225D3106-F49E-4395-9E80-9AC3873206E8}"/>
               </a:ext>
             </a:extLst>
           </p:cNvPr>
@@ -9164,7 +9169,7 @@
           <p:cNvPr id="13" name="">
             <a:extLst xmlns:a="http://schemas.openxmlformats.org/drawingml/2006/main">
               <a:ext uri="{FF2B5EF4-FFF2-40B4-BE49-F238E27FC236}">
-                <a16:creationId xmlns:a16="http://schemas.microsoft.com/office/drawing/2014/main" id="{F8B4FCA5-B51B-4E4B-9EC6-068A27FDAB79}"/>
+                <a16:creationId xmlns:a16="http://schemas.microsoft.com/office/drawing/2014/main" id="{A0B466CD-043F-45EA-A3E5-0F76E331C475}"/>
               </a:ext>
             </a:extLst>
           </p:cNvPr>
@@ -9230,7 +9235,7 @@
           <p:cNvPr id="14" name="">
             <a:extLst xmlns:a="http://schemas.openxmlformats.org/drawingml/2006/main">
               <a:ext uri="{FF2B5EF4-FFF2-40B4-BE49-F238E27FC236}">
-                <a16:creationId xmlns:a16="http://schemas.microsoft.com/office/drawing/2014/main" id="{3716434E-651B-4804-8EDD-0A5F4561D4DC}"/>
+                <a16:creationId xmlns:a16="http://schemas.microsoft.com/office/drawing/2014/main" id="{5A9A4DF5-0DF4-4DCA-A82F-CC2926416510}"/>
               </a:ext>
             </a:extLst>
           </p:cNvPr>
@@ -9296,7 +9301,7 @@
           <p:cNvPr id="15" name="">
             <a:extLst xmlns:a="http://schemas.openxmlformats.org/drawingml/2006/main">
               <a:ext uri="{FF2B5EF4-FFF2-40B4-BE49-F238E27FC236}">
-                <a16:creationId xmlns:a16="http://schemas.microsoft.com/office/drawing/2014/main" id="{7A88DE09-1C4C-4ACD-ABFA-0710003E4163}"/>
+                <a16:creationId xmlns:a16="http://schemas.microsoft.com/office/drawing/2014/main" id="{2C6D095E-9A5B-4E4B-98E9-38338B0277F2}"/>
               </a:ext>
             </a:extLst>
           </p:cNvPr>
@@ -9385,7 +9390,7 @@
           <p:cNvPr id="16" name="">
             <a:extLst xmlns:a="http://schemas.openxmlformats.org/drawingml/2006/main">
               <a:ext uri="{FF2B5EF4-FFF2-40B4-BE49-F238E27FC236}">
-                <a16:creationId xmlns:a16="http://schemas.microsoft.com/office/drawing/2014/main" id="{8039BF5A-A437-4B2B-B579-BCFA5691511B}"/>
+                <a16:creationId xmlns:a16="http://schemas.microsoft.com/office/drawing/2014/main" id="{F06F628D-F2A9-4018-A0DE-46197BA96F0F}"/>
               </a:ext>
             </a:extLst>
           </p:cNvPr>
@@ -9474,7 +9479,7 @@
           <p:cNvPr id="17" name="">
             <a:extLst xmlns:a="http://schemas.openxmlformats.org/drawingml/2006/main">
               <a:ext uri="{FF2B5EF4-FFF2-40B4-BE49-F238E27FC236}">
-                <a16:creationId xmlns:a16="http://schemas.microsoft.com/office/drawing/2014/main" id="{F28C6632-8072-4AC0-ACD8-99FC7BD20E09}"/>
+                <a16:creationId xmlns:a16="http://schemas.microsoft.com/office/drawing/2014/main" id="{814CDD95-03BE-4A47-A6CA-ED4764EB1C2F}"/>
               </a:ext>
             </a:extLst>
           </p:cNvPr>
@@ -9540,7 +9545,7 @@
           <p:cNvPr id="18" name="">
             <a:extLst xmlns:a="http://schemas.openxmlformats.org/drawingml/2006/main">
               <a:ext uri="{FF2B5EF4-FFF2-40B4-BE49-F238E27FC236}">
-                <a16:creationId xmlns:a16="http://schemas.microsoft.com/office/drawing/2014/main" id="{3FDC6240-961F-4D25-894C-917D53BEB57E}"/>
+                <a16:creationId xmlns:a16="http://schemas.microsoft.com/office/drawing/2014/main" id="{67309E44-1166-42DE-9603-9E2EC85D1378}"/>
               </a:ext>
             </a:extLst>
           </p:cNvPr>
@@ -9606,7 +9611,7 @@
           <p:cNvPr id="19" name="">
             <a:extLst xmlns:a="http://schemas.openxmlformats.org/drawingml/2006/main">
               <a:ext uri="{FF2B5EF4-FFF2-40B4-BE49-F238E27FC236}">
-                <a16:creationId xmlns:a16="http://schemas.microsoft.com/office/drawing/2014/main" id="{A287203B-6E84-4784-A62B-C45AC3D59A5D}"/>
+                <a16:creationId xmlns:a16="http://schemas.microsoft.com/office/drawing/2014/main" id="{BEB323F4-A7CF-43B5-8625-6A4F41BE40EF}"/>
               </a:ext>
             </a:extLst>
           </p:cNvPr>
@@ -9636,7 +9641,7 @@
           <p:cNvPr id="20" name="">
             <a:extLst xmlns:a="http://schemas.openxmlformats.org/drawingml/2006/main">
               <a:ext uri="{FF2B5EF4-FFF2-40B4-BE49-F238E27FC236}">
-                <a16:creationId xmlns:a16="http://schemas.microsoft.com/office/drawing/2014/main" id="{BA7EBDD4-6115-43D2-BA3C-0C75C0841AC3}"/>
+                <a16:creationId xmlns:a16="http://schemas.microsoft.com/office/drawing/2014/main" id="{753B452C-D30C-4454-8118-09668E374503}"/>
               </a:ext>
             </a:extLst>
           </p:cNvPr>
@@ -9702,7 +9707,7 @@
           <p:cNvPr id="21" name="">
             <a:extLst xmlns:a="http://schemas.openxmlformats.org/drawingml/2006/main">
               <a:ext uri="{FF2B5EF4-FFF2-40B4-BE49-F238E27FC236}">
-                <a16:creationId xmlns:a16="http://schemas.microsoft.com/office/drawing/2014/main" id="{F17EF61E-63FA-488C-99B0-9B147BCE3558}"/>
+                <a16:creationId xmlns:a16="http://schemas.microsoft.com/office/drawing/2014/main" id="{71BCF337-D09E-4C1C-8019-E2CAB80C4BF7}"/>
               </a:ext>
             </a:extLst>
           </p:cNvPr>
@@ -9768,7 +9773,7 @@
           <p:cNvPr id="22" name="">
             <a:extLst xmlns:a="http://schemas.openxmlformats.org/drawingml/2006/main">
               <a:ext uri="{FF2B5EF4-FFF2-40B4-BE49-F238E27FC236}">
-                <a16:creationId xmlns:a16="http://schemas.microsoft.com/office/drawing/2014/main" id="{CE94FF15-D7C5-4D1D-BD9C-E85B39DC2B41}"/>
+                <a16:creationId xmlns:a16="http://schemas.microsoft.com/office/drawing/2014/main" id="{DD869E50-5C78-4D38-B1AF-A9D8AE8A9CF2}"/>
               </a:ext>
             </a:extLst>
           </p:cNvPr>
@@ -9798,7 +9803,7 @@
           <p:cNvPr id="23" name="">
             <a:extLst xmlns:a="http://schemas.openxmlformats.org/drawingml/2006/main">
               <a:ext uri="{FF2B5EF4-FFF2-40B4-BE49-F238E27FC236}">
-                <a16:creationId xmlns:a16="http://schemas.microsoft.com/office/drawing/2014/main" id="{66142D3A-27B9-46AF-9F83-3DA362105E6D}"/>
+                <a16:creationId xmlns:a16="http://schemas.microsoft.com/office/drawing/2014/main" id="{69C9E3FB-6FCA-4BFA-8F43-811B94A1E75B}"/>
               </a:ext>
             </a:extLst>
           </p:cNvPr>
@@ -9864,7 +9869,7 @@
           <p:cNvPr id="24" name="">
             <a:extLst xmlns:a="http://schemas.openxmlformats.org/drawingml/2006/main">
               <a:ext uri="{FF2B5EF4-FFF2-40B4-BE49-F238E27FC236}">
-                <a16:creationId xmlns:a16="http://schemas.microsoft.com/office/drawing/2014/main" id="{AF79D207-A4A5-4E71-AB6F-E2928636DAD9}"/>
+                <a16:creationId xmlns:a16="http://schemas.microsoft.com/office/drawing/2014/main" id="{54CC0FAD-607C-409D-93C4-3BF36C135ACD}"/>
               </a:ext>
             </a:extLst>
           </p:cNvPr>
@@ -9930,7 +9935,7 @@
           <p:cNvPr id="25" name="">
             <a:extLst xmlns:a="http://schemas.openxmlformats.org/drawingml/2006/main">
               <a:ext uri="{FF2B5EF4-FFF2-40B4-BE49-F238E27FC236}">
-                <a16:creationId xmlns:a16="http://schemas.microsoft.com/office/drawing/2014/main" id="{0184B821-D2E1-401A-A70A-0E49B18729D6}"/>
+                <a16:creationId xmlns:a16="http://schemas.microsoft.com/office/drawing/2014/main" id="{1A47F730-137D-4944-9540-14C4E9A68A83}"/>
               </a:ext>
             </a:extLst>
           </p:cNvPr>
@@ -9960,7 +9965,7 @@
           <p:cNvPr id="26" name="">
             <a:extLst xmlns:a="http://schemas.openxmlformats.org/drawingml/2006/main">
               <a:ext uri="{FF2B5EF4-FFF2-40B4-BE49-F238E27FC236}">
-                <a16:creationId xmlns:a16="http://schemas.microsoft.com/office/drawing/2014/main" id="{AF7BF4E8-804A-408C-A28D-EB6B083BCD8C}"/>
+                <a16:creationId xmlns:a16="http://schemas.microsoft.com/office/drawing/2014/main" id="{DE0A939E-97BC-4275-A028-C25FB0F619E1}"/>
               </a:ext>
             </a:extLst>
           </p:cNvPr>
@@ -10026,7 +10031,7 @@
           <p:cNvPr id="27" name="">
             <a:extLst xmlns:a="http://schemas.openxmlformats.org/drawingml/2006/main">
               <a:ext uri="{FF2B5EF4-FFF2-40B4-BE49-F238E27FC236}">
-                <a16:creationId xmlns:a16="http://schemas.microsoft.com/office/drawing/2014/main" id="{380724F8-0216-425C-BBA9-BC9FCD9D961D}"/>
+                <a16:creationId xmlns:a16="http://schemas.microsoft.com/office/drawing/2014/main" id="{5B3E7846-F689-47C0-B9DD-C8C726D4910C}"/>
               </a:ext>
             </a:extLst>
           </p:cNvPr>
@@ -10092,7 +10097,7 @@
           <p:cNvPr id="28" name="">
             <a:extLst xmlns:a="http://schemas.openxmlformats.org/drawingml/2006/main">
               <a:ext uri="{FF2B5EF4-FFF2-40B4-BE49-F238E27FC236}">
-                <a16:creationId xmlns:a16="http://schemas.microsoft.com/office/drawing/2014/main" id="{5033DB98-E3D7-4578-B6B1-4EBBE20D75AC}"/>
+                <a16:creationId xmlns:a16="http://schemas.microsoft.com/office/drawing/2014/main" id="{BDF50E81-D17E-4E1E-9635-9AAB66DE837F}"/>
               </a:ext>
             </a:extLst>
           </p:cNvPr>
@@ -10158,7 +10163,7 @@
           <p:cNvPr id="29" name="">
             <a:extLst xmlns:a="http://schemas.openxmlformats.org/drawingml/2006/main">
               <a:ext uri="{FF2B5EF4-FFF2-40B4-BE49-F238E27FC236}">
-                <a16:creationId xmlns:a16="http://schemas.microsoft.com/office/drawing/2014/main" id="{F10FC7EC-9BDB-4E03-BA2E-6B3B2D78C1ED}"/>
+                <a16:creationId xmlns:a16="http://schemas.microsoft.com/office/drawing/2014/main" id="{ADEA972A-52BC-4373-B6C8-332B876F0E6A}"/>
               </a:ext>
             </a:extLst>
           </p:cNvPr>
@@ -10224,7 +10229,7 @@
           <p:cNvPr id="30" name="">
             <a:extLst xmlns:a="http://schemas.openxmlformats.org/drawingml/2006/main">
               <a:ext uri="{FF2B5EF4-FFF2-40B4-BE49-F238E27FC236}">
-                <a16:creationId xmlns:a16="http://schemas.microsoft.com/office/drawing/2014/main" id="{7B08E7C0-3100-44B6-AD4E-5A4E404DCE28}"/>
+                <a16:creationId xmlns:a16="http://schemas.microsoft.com/office/drawing/2014/main" id="{20C091B4-B8D9-4F0C-9BFF-CB8E395544E5}"/>
               </a:ext>
             </a:extLst>
           </p:cNvPr>
@@ -10313,7 +10318,7 @@
           <p:cNvPr id="31" name="">
             <a:extLst xmlns:a="http://schemas.openxmlformats.org/drawingml/2006/main">
               <a:ext uri="{FF2B5EF4-FFF2-40B4-BE49-F238E27FC236}">
-                <a16:creationId xmlns:a16="http://schemas.microsoft.com/office/drawing/2014/main" id="{C9048343-BB66-4600-85B9-2DB5E2299671}"/>
+                <a16:creationId xmlns:a16="http://schemas.microsoft.com/office/drawing/2014/main" id="{47ACD623-F133-40B8-8BAA-54D00A328566}"/>
               </a:ext>
             </a:extLst>
           </p:cNvPr>
@@ -10379,7 +10384,7 @@
           <p:cNvPr id="32" name="">
             <a:extLst xmlns:a="http://schemas.openxmlformats.org/drawingml/2006/main">
               <a:ext uri="{FF2B5EF4-FFF2-40B4-BE49-F238E27FC236}">
-                <a16:creationId xmlns:a16="http://schemas.microsoft.com/office/drawing/2014/main" id="{393FF21F-C609-4766-9C1D-DABD54370931}"/>
+                <a16:creationId xmlns:a16="http://schemas.microsoft.com/office/drawing/2014/main" id="{12E86B50-E83B-4228-B563-E1F542170011}"/>
               </a:ext>
             </a:extLst>
           </p:cNvPr>
@@ -10445,7 +10450,7 @@
           <p:cNvPr id="33" name="">
             <a:extLst xmlns:a="http://schemas.openxmlformats.org/drawingml/2006/main">
               <a:ext uri="{FF2B5EF4-FFF2-40B4-BE49-F238E27FC236}">
-                <a16:creationId xmlns:a16="http://schemas.microsoft.com/office/drawing/2014/main" id="{4869EFBF-FEE9-40E0-91E4-2C6D37D97589}"/>
+                <a16:creationId xmlns:a16="http://schemas.microsoft.com/office/drawing/2014/main" id="{70CAA674-A640-4B63-91B7-EB906DF52713}"/>
               </a:ext>
             </a:extLst>
           </p:cNvPr>
@@ -10475,7 +10480,7 @@
           <p:cNvPr id="34" name="">
             <a:extLst xmlns:a="http://schemas.openxmlformats.org/drawingml/2006/main">
               <a:ext uri="{FF2B5EF4-FFF2-40B4-BE49-F238E27FC236}">
-                <a16:creationId xmlns:a16="http://schemas.microsoft.com/office/drawing/2014/main" id="{A18E32D3-10A3-4325-A6AC-80D2798F215E}"/>
+                <a16:creationId xmlns:a16="http://schemas.microsoft.com/office/drawing/2014/main" id="{EE6F5C79-EB35-479C-97DD-7AE8E132B029}"/>
               </a:ext>
             </a:extLst>
           </p:cNvPr>
@@ -10541,7 +10546,7 @@
           <p:cNvPr id="35" name="">
             <a:extLst xmlns:a="http://schemas.openxmlformats.org/drawingml/2006/main">
               <a:ext uri="{FF2B5EF4-FFF2-40B4-BE49-F238E27FC236}">
-                <a16:creationId xmlns:a16="http://schemas.microsoft.com/office/drawing/2014/main" id="{DA749540-87C9-477B-84FE-545C270135A3}"/>
+                <a16:creationId xmlns:a16="http://schemas.microsoft.com/office/drawing/2014/main" id="{79164A59-DE52-41BC-9DD7-DB149C82095E}"/>
               </a:ext>
             </a:extLst>
           </p:cNvPr>
@@ -10607,7 +10612,7 @@
           <p:cNvPr id="36" name="">
             <a:extLst xmlns:a="http://schemas.openxmlformats.org/drawingml/2006/main">
               <a:ext uri="{FF2B5EF4-FFF2-40B4-BE49-F238E27FC236}">
-                <a16:creationId xmlns:a16="http://schemas.microsoft.com/office/drawing/2014/main" id="{3F056AF7-38C3-4A68-814F-34615E7BD496}"/>
+                <a16:creationId xmlns:a16="http://schemas.microsoft.com/office/drawing/2014/main" id="{257FC9AF-9AD0-4DB7-91A7-CF3816806D56}"/>
               </a:ext>
             </a:extLst>
           </p:cNvPr>
@@ -10637,7 +10642,7 @@
           <p:cNvPr id="37" name="">
             <a:extLst xmlns:a="http://schemas.openxmlformats.org/drawingml/2006/main">
               <a:ext uri="{FF2B5EF4-FFF2-40B4-BE49-F238E27FC236}">
-                <a16:creationId xmlns:a16="http://schemas.microsoft.com/office/drawing/2014/main" id="{119C8F19-8628-4902-9F3C-7B7F23F83BD6}"/>
+                <a16:creationId xmlns:a16="http://schemas.microsoft.com/office/drawing/2014/main" id="{4830F0BA-AA3F-4C68-9263-7BF71C0E30C5}"/>
               </a:ext>
             </a:extLst>
           </p:cNvPr>
@@ -10703,7 +10708,7 @@
           <p:cNvPr id="38" name="">
             <a:extLst xmlns:a="http://schemas.openxmlformats.org/drawingml/2006/main">
               <a:ext uri="{FF2B5EF4-FFF2-40B4-BE49-F238E27FC236}">
-                <a16:creationId xmlns:a16="http://schemas.microsoft.com/office/drawing/2014/main" id="{87CC5A38-A30B-42BA-8057-A5AA84F8953C}"/>
+                <a16:creationId xmlns:a16="http://schemas.microsoft.com/office/drawing/2014/main" id="{E212829D-62C0-4248-B28E-3B3ECEE89AF9}"/>
               </a:ext>
             </a:extLst>
           </p:cNvPr>
@@ -10769,7 +10774,7 @@
           <p:cNvPr id="39" name="">
             <a:extLst xmlns:a="http://schemas.openxmlformats.org/drawingml/2006/main">
               <a:ext uri="{FF2B5EF4-FFF2-40B4-BE49-F238E27FC236}">
-                <a16:creationId xmlns:a16="http://schemas.microsoft.com/office/drawing/2014/main" id="{6542C334-E1B3-40A9-A5B6-10906306028C}"/>
+                <a16:creationId xmlns:a16="http://schemas.microsoft.com/office/drawing/2014/main" id="{A840E25C-83EE-4385-999E-829EEEEF901A}"/>
               </a:ext>
             </a:extLst>
           </p:cNvPr>
@@ -10799,7 +10804,7 @@
           <p:cNvPr id="40" name="">
             <a:extLst xmlns:a="http://schemas.openxmlformats.org/drawingml/2006/main">
               <a:ext uri="{FF2B5EF4-FFF2-40B4-BE49-F238E27FC236}">
-                <a16:creationId xmlns:a16="http://schemas.microsoft.com/office/drawing/2014/main" id="{2636F55C-8E5C-45FB-A9B6-AB1371A49C89}"/>
+                <a16:creationId xmlns:a16="http://schemas.microsoft.com/office/drawing/2014/main" id="{05255DD7-3A16-4D61-937C-73EC9EB5C2C8}"/>
               </a:ext>
             </a:extLst>
           </p:cNvPr>
@@ -10865,7 +10870,7 @@
           <p:cNvPr id="41" name="">
             <a:extLst xmlns:a="http://schemas.openxmlformats.org/drawingml/2006/main">
               <a:ext uri="{FF2B5EF4-FFF2-40B4-BE49-F238E27FC236}">
-                <a16:creationId xmlns:a16="http://schemas.microsoft.com/office/drawing/2014/main" id="{FFDBBA42-370C-4DF8-A38B-2118E67AF77E}"/>
+                <a16:creationId xmlns:a16="http://schemas.microsoft.com/office/drawing/2014/main" id="{A3F3B611-7A88-4B2F-9F41-BB14522C54D0}"/>
               </a:ext>
             </a:extLst>
           </p:cNvPr>
@@ -10931,7 +10936,7 @@
           <p:cNvPr id="42" name="">
             <a:extLst xmlns:a="http://schemas.openxmlformats.org/drawingml/2006/main">
               <a:ext uri="{FF2B5EF4-FFF2-40B4-BE49-F238E27FC236}">
-                <a16:creationId xmlns:a16="http://schemas.microsoft.com/office/drawing/2014/main" id="{714745C9-EF79-4E4D-8F55-CF73486B5141}"/>
+                <a16:creationId xmlns:a16="http://schemas.microsoft.com/office/drawing/2014/main" id="{B30B6CB7-4C76-4C1D-A081-51919676D101}"/>
               </a:ext>
             </a:extLst>
           </p:cNvPr>
@@ -10997,7 +11002,7 @@
           <p:cNvPr id="43" name="">
             <a:extLst xmlns:a="http://schemas.openxmlformats.org/drawingml/2006/main">
               <a:ext uri="{FF2B5EF4-FFF2-40B4-BE49-F238E27FC236}">
-                <a16:creationId xmlns:a16="http://schemas.microsoft.com/office/drawing/2014/main" id="{E08E25EA-801C-4346-AFF0-1596A03BF300}"/>
+                <a16:creationId xmlns:a16="http://schemas.microsoft.com/office/drawing/2014/main" id="{53417210-8EA1-47C4-BB6F-C09A39A3332D}"/>
               </a:ext>
             </a:extLst>
           </p:cNvPr>
@@ -11063,7 +11068,7 @@
           <p:cNvPr id="44" name="">
             <a:extLst xmlns:a="http://schemas.openxmlformats.org/drawingml/2006/main">
               <a:ext uri="{FF2B5EF4-FFF2-40B4-BE49-F238E27FC236}">
-                <a16:creationId xmlns:a16="http://schemas.microsoft.com/office/drawing/2014/main" id="{7016282C-336B-4D33-82A5-139E07037573}"/>
+                <a16:creationId xmlns:a16="http://schemas.microsoft.com/office/drawing/2014/main" id="{B14920BD-92C9-49DA-8F3E-BDEEEE440EB3}"/>
               </a:ext>
             </a:extLst>
           </p:cNvPr>
@@ -11152,7 +11157,7 @@
           <p:cNvPr id="45" name="">
             <a:extLst xmlns:a="http://schemas.openxmlformats.org/drawingml/2006/main">
               <a:ext uri="{FF2B5EF4-FFF2-40B4-BE49-F238E27FC236}">
-                <a16:creationId xmlns:a16="http://schemas.microsoft.com/office/drawing/2014/main" id="{09AC07DF-A687-41EC-9D4A-379F22565FEE}"/>
+                <a16:creationId xmlns:a16="http://schemas.microsoft.com/office/drawing/2014/main" id="{A25144DF-1A86-40B3-B716-7006925A4CC4}"/>
               </a:ext>
             </a:extLst>
           </p:cNvPr>
@@ -11216,7 +11221,7 @@
     </p:spTree>
     <p:extLst>
       <p:ext uri="{BB962C8B-B14F-4D97-AF65-F5344CB8AC3E}">
-        <p14:creationId xmlns:p14="http://schemas.microsoft.com/office/powerpoint/2010/main" val="1476580172"/>
+        <p14:creationId xmlns:p14="http://schemas.microsoft.com/office/powerpoint/2010/main" val="870338331"/>
       </p:ext>
     </p:extLst>
   </p:cSld>
@@ -11247,7 +11252,7 @@
           <p:cNvPr id="18" name="">
             <a:extLst xmlns:a="http://schemas.openxmlformats.org/drawingml/2006/main">
               <a:ext uri="{FF2B5EF4-FFF2-40B4-BE49-F238E27FC236}">
-                <a16:creationId xmlns:a16="http://schemas.microsoft.com/office/drawing/2014/main" id="{6D024117-2A93-4F45-B72B-E05613133DC2}"/>
+                <a16:creationId xmlns:a16="http://schemas.microsoft.com/office/drawing/2014/main" id="{235BCA28-7A83-4007-96F1-A22307DCAB44}"/>
               </a:ext>
             </a:extLst>
           </p:cNvPr>
@@ -11313,7 +11318,7 @@
           <p:cNvPr id="2" name="">
             <a:extLst xmlns:a="http://schemas.openxmlformats.org/drawingml/2006/main">
               <a:ext uri="{FF2B5EF4-FFF2-40B4-BE49-F238E27FC236}">
-                <a16:creationId xmlns:a16="http://schemas.microsoft.com/office/drawing/2014/main" id="{440035F4-5C64-4A9F-B0AA-7680194CE23B}"/>
+                <a16:creationId xmlns:a16="http://schemas.microsoft.com/office/drawing/2014/main" id="{3F627999-83F7-4E7A-9D7B-F56C90D704D7}"/>
               </a:ext>
             </a:extLst>
           </p:cNvPr>
@@ -11379,7 +11384,7 @@
           <p:cNvPr id="3" name="">
             <a:extLst xmlns:a="http://schemas.openxmlformats.org/drawingml/2006/main">
               <a:ext uri="{FF2B5EF4-FFF2-40B4-BE49-F238E27FC236}">
-                <a16:creationId xmlns:a16="http://schemas.microsoft.com/office/drawing/2014/main" id="{CB50257A-A159-41E9-9894-7DB8185E514E}"/>
+                <a16:creationId xmlns:a16="http://schemas.microsoft.com/office/drawing/2014/main" id="{0996ED5F-7586-4BFD-B6A3-9DF04C024069}"/>
               </a:ext>
             </a:extLst>
           </p:cNvPr>
@@ -11445,7 +11450,7 @@
           <p:cNvPr id="4" name="">
             <a:extLst xmlns:a="http://schemas.openxmlformats.org/drawingml/2006/main">
               <a:ext uri="{FF2B5EF4-FFF2-40B4-BE49-F238E27FC236}">
-                <a16:creationId xmlns:a16="http://schemas.microsoft.com/office/drawing/2014/main" id="{35CFF698-B3B1-4E38-9DEF-9208613563A4}"/>
+                <a16:creationId xmlns:a16="http://schemas.microsoft.com/office/drawing/2014/main" id="{9E5FF312-D9D9-4757-9B1B-E004285B4BA3}"/>
               </a:ext>
             </a:extLst>
           </p:cNvPr>
@@ -11475,7 +11480,7 @@
           <p:cNvPr id="5" name="">
             <a:extLst xmlns:a="http://schemas.openxmlformats.org/drawingml/2006/main">
               <a:ext uri="{FF2B5EF4-FFF2-40B4-BE49-F238E27FC236}">
-                <a16:creationId xmlns:a16="http://schemas.microsoft.com/office/drawing/2014/main" id="{B6D427C6-E2C0-4E5A-8247-66DDF6659AC3}"/>
+                <a16:creationId xmlns:a16="http://schemas.microsoft.com/office/drawing/2014/main" id="{68BF6257-0F0F-4857-92FC-E1539C571318}"/>
               </a:ext>
             </a:extLst>
           </p:cNvPr>
@@ -11505,7 +11510,7 @@
           <p:cNvPr id="6" name="">
             <a:extLst xmlns:a="http://schemas.openxmlformats.org/drawingml/2006/main">
               <a:ext uri="{FF2B5EF4-FFF2-40B4-BE49-F238E27FC236}">
-                <a16:creationId xmlns:a16="http://schemas.microsoft.com/office/drawing/2014/main" id="{452AE3BB-6000-487D-9F57-43D0D73BB2AB}"/>
+                <a16:creationId xmlns:a16="http://schemas.microsoft.com/office/drawing/2014/main" id="{94DAA2A4-F229-4110-9293-B4AB382B74C5}"/>
               </a:ext>
             </a:extLst>
           </p:cNvPr>
@@ -11535,7 +11540,7 @@
           <p:cNvPr id="7" name="">
             <a:extLst xmlns:a="http://schemas.openxmlformats.org/drawingml/2006/main">
               <a:ext uri="{FF2B5EF4-FFF2-40B4-BE49-F238E27FC236}">
-                <a16:creationId xmlns:a16="http://schemas.microsoft.com/office/drawing/2014/main" id="{4FBDCF10-14A5-4FDD-9F7B-DCC9E28B6F06}"/>
+                <a16:creationId xmlns:a16="http://schemas.microsoft.com/office/drawing/2014/main" id="{04428BFB-3BCA-47EF-B27F-5C980B07A099}"/>
               </a:ext>
             </a:extLst>
           </p:cNvPr>
@@ -11601,7 +11606,7 @@
           <p:cNvPr id="8" name="">
             <a:extLst xmlns:a="http://schemas.openxmlformats.org/drawingml/2006/main">
               <a:ext uri="{FF2B5EF4-FFF2-40B4-BE49-F238E27FC236}">
-                <a16:creationId xmlns:a16="http://schemas.microsoft.com/office/drawing/2014/main" id="{C59163D8-DEF9-46F9-8E57-E1ED566CC93D}"/>
+                <a16:creationId xmlns:a16="http://schemas.microsoft.com/office/drawing/2014/main" id="{03880AAD-AF99-40D1-A7D0-272F3EB7A477}"/>
               </a:ext>
             </a:extLst>
           </p:cNvPr>
@@ -11690,7 +11695,7 @@
           <p:cNvPr id="9" name="">
             <a:extLst xmlns:a="http://schemas.openxmlformats.org/drawingml/2006/main">
               <a:ext uri="{FF2B5EF4-FFF2-40B4-BE49-F238E27FC236}">
-                <a16:creationId xmlns:a16="http://schemas.microsoft.com/office/drawing/2014/main" id="{4B8A53D6-A969-4B10-B16F-E18B63903988}"/>
+                <a16:creationId xmlns:a16="http://schemas.microsoft.com/office/drawing/2014/main" id="{4E342CDB-B529-4895-8AB9-C62065CCC7FE}"/>
               </a:ext>
             </a:extLst>
           </p:cNvPr>
@@ -11779,7 +11784,7 @@
           <p:cNvPr id="10" name="">
             <a:extLst xmlns:a="http://schemas.openxmlformats.org/drawingml/2006/main">
               <a:ext uri="{FF2B5EF4-FFF2-40B4-BE49-F238E27FC236}">
-                <a16:creationId xmlns:a16="http://schemas.microsoft.com/office/drawing/2014/main" id="{8318B8F3-E2D4-4667-8314-433B3FA545E3}"/>
+                <a16:creationId xmlns:a16="http://schemas.microsoft.com/office/drawing/2014/main" id="{7D0A54BB-FD40-4799-93D0-9B9C24451DC9}"/>
               </a:ext>
             </a:extLst>
           </p:cNvPr>
@@ -11845,7 +11850,7 @@
           <p:cNvPr id="11" name="">
             <a:extLst xmlns:a="http://schemas.openxmlformats.org/drawingml/2006/main">
               <a:ext uri="{FF2B5EF4-FFF2-40B4-BE49-F238E27FC236}">
-                <a16:creationId xmlns:a16="http://schemas.microsoft.com/office/drawing/2014/main" id="{386463BB-5FF3-45FD-B08B-A68D77406421}"/>
+                <a16:creationId xmlns:a16="http://schemas.microsoft.com/office/drawing/2014/main" id="{507B98A4-FDFB-4FF6-9DBB-7A5825D4EDE5}"/>
               </a:ext>
             </a:extLst>
           </p:cNvPr>
@@ -11911,7 +11916,7 @@
           <p:cNvPr id="12" name="">
             <a:extLst xmlns:a="http://schemas.openxmlformats.org/drawingml/2006/main">
               <a:ext uri="{FF2B5EF4-FFF2-40B4-BE49-F238E27FC236}">
-                <a16:creationId xmlns:a16="http://schemas.microsoft.com/office/drawing/2014/main" id="{BA202225-FE1E-4713-BAF8-7705591F2591}"/>
+                <a16:creationId xmlns:a16="http://schemas.microsoft.com/office/drawing/2014/main" id="{C0C7569A-6407-411E-9374-D7000589A7AD}"/>
               </a:ext>
             </a:extLst>
           </p:cNvPr>
@@ -12023,7 +12028,7 @@
           <p:cNvPr id="13" name="">
             <a:extLst xmlns:a="http://schemas.openxmlformats.org/drawingml/2006/main">
               <a:ext uri="{FF2B5EF4-FFF2-40B4-BE49-F238E27FC236}">
-                <a16:creationId xmlns:a16="http://schemas.microsoft.com/office/drawing/2014/main" id="{A52F0C90-4D14-4587-8E5B-16C547B1D17F}"/>
+                <a16:creationId xmlns:a16="http://schemas.microsoft.com/office/drawing/2014/main" id="{B77C296D-B94B-4C8B-B656-D3E6CE527C8F}"/>
               </a:ext>
             </a:extLst>
           </p:cNvPr>
@@ -12112,7 +12117,7 @@
           <p:cNvPr id="14" name="">
             <a:extLst xmlns:a="http://schemas.openxmlformats.org/drawingml/2006/main">
               <a:ext uri="{FF2B5EF4-FFF2-40B4-BE49-F238E27FC236}">
-                <a16:creationId xmlns:a16="http://schemas.microsoft.com/office/drawing/2014/main" id="{F8A04E1C-0102-4CEB-BD75-433ADF548AD8}"/>
+                <a16:creationId xmlns:a16="http://schemas.microsoft.com/office/drawing/2014/main" id="{B8D8E82B-35B8-4C81-9047-973506C66BE5}"/>
               </a:ext>
             </a:extLst>
           </p:cNvPr>
@@ -12178,7 +12183,7 @@
           <p:cNvPr id="15" name="">
             <a:extLst xmlns:a="http://schemas.openxmlformats.org/drawingml/2006/main">
               <a:ext uri="{FF2B5EF4-FFF2-40B4-BE49-F238E27FC236}">
-                <a16:creationId xmlns:a16="http://schemas.microsoft.com/office/drawing/2014/main" id="{AEE0BEBE-AE29-4F06-A12E-C3F93C7259D1}"/>
+                <a16:creationId xmlns:a16="http://schemas.microsoft.com/office/drawing/2014/main" id="{A2D72292-2F2E-42E6-A94C-40324DD1A933}"/>
               </a:ext>
             </a:extLst>
           </p:cNvPr>
@@ -12267,7 +12272,7 @@
           <p:cNvPr id="16" name="">
             <a:extLst xmlns:a="http://schemas.openxmlformats.org/drawingml/2006/main">
               <a:ext uri="{FF2B5EF4-FFF2-40B4-BE49-F238E27FC236}">
-                <a16:creationId xmlns:a16="http://schemas.microsoft.com/office/drawing/2014/main" id="{C143B7D1-91C8-41F3-BE88-CE3BC512B3A0}"/>
+                <a16:creationId xmlns:a16="http://schemas.microsoft.com/office/drawing/2014/main" id="{010B4377-C3E0-42C5-B5D6-FB408CFA1098}"/>
               </a:ext>
             </a:extLst>
           </p:cNvPr>
@@ -12333,7 +12338,7 @@
           <p:cNvPr id="17" name="">
             <a:extLst xmlns:a="http://schemas.openxmlformats.org/drawingml/2006/main">
               <a:ext uri="{FF2B5EF4-FFF2-40B4-BE49-F238E27FC236}">
-                <a16:creationId xmlns:a16="http://schemas.microsoft.com/office/drawing/2014/main" id="{25582069-6D70-43F9-9312-A0A547AFCC15}"/>
+                <a16:creationId xmlns:a16="http://schemas.microsoft.com/office/drawing/2014/main" id="{46DC2621-D8EC-4685-B7FE-891A918237F3}"/>
               </a:ext>
             </a:extLst>
           </p:cNvPr>
@@ -12443,7 +12448,7 @@
     </p:spTree>
     <p:extLst>
       <p:ext uri="{BB962C8B-B14F-4D97-AF65-F5344CB8AC3E}">
-        <p14:creationId xmlns:p14="http://schemas.microsoft.com/office/powerpoint/2010/main" val="503650653"/>
+        <p14:creationId xmlns:p14="http://schemas.microsoft.com/office/powerpoint/2010/main" val="2134745050"/>
       </p:ext>
     </p:extLst>
   </p:cSld>
@@ -12471,10 +12476,10 @@
       </p:grpSpPr>
       <p:sp>
         <p:nvSpPr>
-          <p:cNvPr id="23" name="">
+          <p:cNvPr id="20" name="">
             <a:extLst xmlns:a="http://schemas.openxmlformats.org/drawingml/2006/main">
               <a:ext uri="{FF2B5EF4-FFF2-40B4-BE49-F238E27FC236}">
-                <a16:creationId xmlns:a16="http://schemas.microsoft.com/office/drawing/2014/main" id="{35669CD6-8EC0-4263-B783-20F3800E66F5}"/>
+                <a16:creationId xmlns:a16="http://schemas.microsoft.com/office/drawing/2014/main" id="{942AE150-8E70-454C-9ACB-308A1E8BF8D0}"/>
               </a:ext>
             </a:extLst>
           </p:cNvPr>
@@ -12530,7 +12535,7 @@
                 <a:ea typeface="Ubuntu Condensed"/>
                 <a:cs typeface="Ubuntu Condensed"/>
               </a:rPr>
-              <a:t>A country click keeps the whole history</a:t>
+              <a:t>Filtering with the sheet’s funnel icon</a:t>
             </a:r>
           </a:p>
         </p:txBody>
@@ -12540,7 +12545,7 @@
           <p:cNvPr id="2" name="">
             <a:extLst xmlns:a="http://schemas.openxmlformats.org/drawingml/2006/main">
               <a:ext uri="{FF2B5EF4-FFF2-40B4-BE49-F238E27FC236}">
-                <a16:creationId xmlns:a16="http://schemas.microsoft.com/office/drawing/2014/main" id="{86BF6DD4-55A4-4046-875D-6AAE071429CF}"/>
+                <a16:creationId xmlns:a16="http://schemas.microsoft.com/office/drawing/2014/main" id="{F83E1D15-92A1-421E-AB51-468FE13F9EAB}"/>
               </a:ext>
             </a:extLst>
           </p:cNvPr>
@@ -12596,7 +12601,7 @@
                 <a:ea typeface="Ubuntu Condensed"/>
                 <a:cs typeface="Ubuntu Condensed"/>
               </a:rPr>
-              <a:t>Dashboard &gt; Actions &gt; Add Action &gt; Filter</a:t>
+              <a:t>World sheet &gt; Use as Filter</a:t>
             </a:r>
           </a:p>
         </p:txBody>
@@ -12606,7 +12611,7 @@
           <p:cNvPr id="3" name="">
             <a:extLst xmlns:a="http://schemas.openxmlformats.org/drawingml/2006/main">
               <a:ext uri="{FF2B5EF4-FFF2-40B4-BE49-F238E27FC236}">
-                <a16:creationId xmlns:a16="http://schemas.microsoft.com/office/drawing/2014/main" id="{09D5F89B-7401-403E-AE94-17F4F756867E}"/>
+                <a16:creationId xmlns:a16="http://schemas.microsoft.com/office/drawing/2014/main" id="{4EE4613E-7361-432A-A69A-188A13F632C6}"/>
               </a:ext>
             </a:extLst>
           </p:cNvPr>
@@ -12618,73 +12623,7 @@
         <p:spPr>
           <a:xfrm xmlns:a="http://schemas.openxmlformats.org/drawingml/2006/main">
             <a:off x="457200" y="1752600"/>
-            <a:ext cx="5048250" cy="266700"/>
-          </a:xfrm>
-          <a:prstGeom xmlns:a="http://schemas.openxmlformats.org/drawingml/2006/main" prst="rect">
-            <a:avLst/>
-          </a:prstGeom>
-          <a:noFill xmlns:a="http://schemas.openxmlformats.org/drawingml/2006/main"/>
-          <a:ln xmlns:a="http://schemas.openxmlformats.org/drawingml/2006/main" w="0">
-            <a:noFill/>
-          </a:ln>
-        </p:spPr>
-        <p:txBody>
-          <a:bodyPr xmlns:a="http://schemas.openxmlformats.org/drawingml/2006/main" lIns="0" tIns="0" rIns="0" bIns="0"/>
-          <a:lstStyle xmlns:a="http://schemas.openxmlformats.org/drawingml/2006/main">
-            <a:defPPr>
-              <a:defRPr sz="1650">
-                <a:solidFill>
-                  <a:srgbClr val="81796F"/>
-                </a:solidFill>
-                <a:latin typeface="Ubuntu Condensed"/>
-                <a:ea typeface="Ubuntu Condensed"/>
-                <a:cs typeface="Ubuntu Condensed"/>
-              </a:defRPr>
-            </a:defPPr>
-          </a:lstStyle>
-          <a:p xmlns:a="http://schemas.openxmlformats.org/drawingml/2006/main">
-            <a:pPr>
-              <a:defRPr sz="1650">
-                <a:solidFill>
-                  <a:srgbClr val="81796F"/>
-                </a:solidFill>
-                <a:latin typeface="Ubuntu Condensed"/>
-                <a:ea typeface="Ubuntu Condensed"/>
-                <a:cs typeface="Ubuntu Condensed"/>
-              </a:defRPr>
-            </a:pPr>
-            <a:r>
-              <a:rPr sz="1650">
-                <a:solidFill>
-                  <a:srgbClr val="81796F"/>
-                </a:solidFill>
-                <a:latin typeface="Ubuntu Condensed"/>
-                <a:ea typeface="Ubuntu Condensed"/>
-                <a:cs typeface="Ubuntu Condensed"/>
-              </a:rPr>
-              <a:t>Source</a:t>
-            </a:r>
-          </a:p>
-        </p:txBody>
-      </p:sp>
-      <p:sp>
-        <p:nvSpPr>
-          <p:cNvPr id="4" name="">
-            <a:extLst xmlns:a="http://schemas.openxmlformats.org/drawingml/2006/main">
-              <a:ext uri="{FF2B5EF4-FFF2-40B4-BE49-F238E27FC236}">
-                <a16:creationId xmlns:a16="http://schemas.microsoft.com/office/drawing/2014/main" id="{455BD023-1AD4-4F7C-AC1D-C5B4D796C8E0}"/>
-              </a:ext>
-            </a:extLst>
-          </p:cNvPr>
-          <p:cNvSpPr>
-            <a:spLocks xmlns:a="http://schemas.openxmlformats.org/drawingml/2006/main" noGrp="1"/>
-          </p:cNvSpPr>
-          <p:nvPr/>
-        </p:nvSpPr>
-        <p:spPr>
-          <a:xfrm xmlns:a="http://schemas.openxmlformats.org/drawingml/2006/main">
-            <a:off x="457200" y="2047875"/>
-            <a:ext cx="5238750" cy="381000"/>
+            <a:ext cx="5238750" cy="333375"/>
           </a:xfrm>
           <a:prstGeom xmlns:a="http://schemas.openxmlformats.org/drawingml/2006/main" prst="rect">
             <a:avLst/>
@@ -12700,7 +12639,7 @@
             <a:defPPr>
               <a:defRPr sz="2175">
                 <a:solidFill>
-                  <a:srgbClr val="38332E"/>
+                  <a:srgbClr val="B23C50"/>
                 </a:solidFill>
                 <a:latin typeface="Ubuntu Condensed"/>
                 <a:ea typeface="Ubuntu Condensed"/>
@@ -12712,7 +12651,7 @@
             <a:pPr>
               <a:defRPr sz="2175">
                 <a:solidFill>
-                  <a:srgbClr val="38332E"/>
+                  <a:srgbClr val="B23C50"/>
                 </a:solidFill>
                 <a:latin typeface="Ubuntu Condensed"/>
                 <a:ea typeface="Ubuntu Condensed"/>
@@ -12722,23 +12661,23 @@
             <a:r>
               <a:rPr sz="2175">
                 <a:solidFill>
-                  <a:srgbClr val="38332E"/>
+                  <a:srgbClr val="B23C50"/>
                 </a:solidFill>
                 <a:latin typeface="Ubuntu Condensed"/>
                 <a:ea typeface="Ubuntu Condensed"/>
                 <a:cs typeface="Ubuntu Condensed"/>
               </a:rPr>
-              <a:t>World</a:t>
+              <a:t>1  Select the sheet</a:t>
             </a:r>
           </a:p>
         </p:txBody>
       </p:sp>
       <p:sp>
         <p:nvSpPr>
-          <p:cNvPr id="5" name="">
+          <p:cNvPr id="4" name="">
             <a:extLst xmlns:a="http://schemas.openxmlformats.org/drawingml/2006/main">
               <a:ext uri="{FF2B5EF4-FFF2-40B4-BE49-F238E27FC236}">
-                <a16:creationId xmlns:a16="http://schemas.microsoft.com/office/drawing/2014/main" id="{8B2E7CD3-8095-4A5B-8A22-9ED9B346E27F}"/>
+                <a16:creationId xmlns:a16="http://schemas.microsoft.com/office/drawing/2014/main" id="{304AE1B1-68D8-4296-A0EA-EB5DD315CE0A}"/>
               </a:ext>
             </a:extLst>
           </p:cNvPr>
@@ -12749,8 +12688,8 @@
         </p:nvSpPr>
         <p:spPr>
           <a:xfrm xmlns:a="http://schemas.openxmlformats.org/drawingml/2006/main">
-            <a:off x="457200" y="2466975"/>
-            <a:ext cx="5048250" cy="266700"/>
+            <a:off x="457200" y="2143125"/>
+            <a:ext cx="5238750" cy="428625"/>
           </a:xfrm>
           <a:prstGeom xmlns:a="http://schemas.openxmlformats.org/drawingml/2006/main" prst="rect">
             <a:avLst/>
@@ -12764,9 +12703,9 @@
           <a:bodyPr xmlns:a="http://schemas.openxmlformats.org/drawingml/2006/main" lIns="0" tIns="0" rIns="0" bIns="0"/>
           <a:lstStyle xmlns:a="http://schemas.openxmlformats.org/drawingml/2006/main">
             <a:defPPr>
-              <a:defRPr sz="1650">
-                <a:solidFill>
-                  <a:srgbClr val="81796F"/>
+              <a:defRPr sz="2025">
+                <a:solidFill>
+                  <a:srgbClr val="38332E"/>
                 </a:solidFill>
                 <a:latin typeface="Ubuntu Condensed"/>
                 <a:ea typeface="Ubuntu Condensed"/>
@@ -12776,9 +12715,9 @@
           </a:lstStyle>
           <a:p xmlns:a="http://schemas.openxmlformats.org/drawingml/2006/main">
             <a:pPr>
-              <a:defRPr sz="1650">
-                <a:solidFill>
-                  <a:srgbClr val="81796F"/>
+              <a:defRPr sz="2025">
+                <a:solidFill>
+                  <a:srgbClr val="38332E"/>
                 </a:solidFill>
                 <a:latin typeface="Ubuntu Condensed"/>
                 <a:ea typeface="Ubuntu Condensed"/>
@@ -12786,25 +12725,25 @@
               </a:defRPr>
             </a:pPr>
             <a:r>
-              <a:rPr sz="1650">
-                <a:solidFill>
-                  <a:srgbClr val="81796F"/>
+              <a:rPr sz="2025">
+                <a:solidFill>
+                  <a:srgbClr val="38332E"/>
                 </a:solidFill>
                 <a:latin typeface="Ubuntu Condensed"/>
                 <a:ea typeface="Ubuntu Condensed"/>
                 <a:cs typeface="Ubuntu Condensed"/>
               </a:rPr>
-              <a:t>Run on</a:t>
+              <a:t>Click World in the dashboard.</a:t>
             </a:r>
           </a:p>
         </p:txBody>
       </p:sp>
       <p:sp>
         <p:nvSpPr>
-          <p:cNvPr id="6" name="">
+          <p:cNvPr id="5" name="">
             <a:extLst xmlns:a="http://schemas.openxmlformats.org/drawingml/2006/main">
               <a:ext uri="{FF2B5EF4-FFF2-40B4-BE49-F238E27FC236}">
-                <a16:creationId xmlns:a16="http://schemas.microsoft.com/office/drawing/2014/main" id="{E1A99B34-FA22-402B-9A45-10A5AA8DA60F}"/>
+                <a16:creationId xmlns:a16="http://schemas.microsoft.com/office/drawing/2014/main" id="{EEB7094D-1213-4122-9527-5F0C83A86705}"/>
               </a:ext>
             </a:extLst>
           </p:cNvPr>
@@ -12815,8 +12754,8 @@
         </p:nvSpPr>
         <p:spPr>
           <a:xfrm xmlns:a="http://schemas.openxmlformats.org/drawingml/2006/main">
-            <a:off x="457200" y="2762250"/>
-            <a:ext cx="5238750" cy="381000"/>
+            <a:off x="457200" y="2705100"/>
+            <a:ext cx="5238750" cy="333375"/>
           </a:xfrm>
           <a:prstGeom xmlns:a="http://schemas.openxmlformats.org/drawingml/2006/main" prst="rect">
             <a:avLst/>
@@ -12832,7 +12771,7 @@
             <a:defPPr>
               <a:defRPr sz="2175">
                 <a:solidFill>
-                  <a:srgbClr val="38332E"/>
+                  <a:srgbClr val="B23C50"/>
                 </a:solidFill>
                 <a:latin typeface="Ubuntu Condensed"/>
                 <a:ea typeface="Ubuntu Condensed"/>
@@ -12844,7 +12783,7 @@
             <a:pPr>
               <a:defRPr sz="2175">
                 <a:solidFill>
-                  <a:srgbClr val="38332E"/>
+                  <a:srgbClr val="B23C50"/>
                 </a:solidFill>
                 <a:latin typeface="Ubuntu Condensed"/>
                 <a:ea typeface="Ubuntu Condensed"/>
@@ -12854,23 +12793,23 @@
             <a:r>
               <a:rPr sz="2175">
                 <a:solidFill>
-                  <a:srgbClr val="38332E"/>
+                  <a:srgbClr val="B23C50"/>
                 </a:solidFill>
                 <a:latin typeface="Ubuntu Condensed"/>
                 <a:ea typeface="Ubuntu Condensed"/>
                 <a:cs typeface="Ubuntu Condensed"/>
               </a:rPr>
-              <a:t>Select</a:t>
+              <a:t>2  Use as Filter</a:t>
             </a:r>
           </a:p>
         </p:txBody>
       </p:sp>
       <p:sp>
         <p:nvSpPr>
-          <p:cNvPr id="7" name="">
+          <p:cNvPr id="6" name="">
             <a:extLst xmlns:a="http://schemas.openxmlformats.org/drawingml/2006/main">
               <a:ext uri="{FF2B5EF4-FFF2-40B4-BE49-F238E27FC236}">
-                <a16:creationId xmlns:a16="http://schemas.microsoft.com/office/drawing/2014/main" id="{B48B875B-FAA5-41EB-ABB3-B9315A9EA07D}"/>
+                <a16:creationId xmlns:a16="http://schemas.microsoft.com/office/drawing/2014/main" id="{9674B9D4-6686-4CCB-A1DD-E8F80EDA7E29}"/>
               </a:ext>
             </a:extLst>
           </p:cNvPr>
@@ -12881,8 +12820,8 @@
         </p:nvSpPr>
         <p:spPr>
           <a:xfrm xmlns:a="http://schemas.openxmlformats.org/drawingml/2006/main">
-            <a:off x="457200" y="3181350"/>
-            <a:ext cx="5048250" cy="266700"/>
+            <a:off x="457200" y="3095625"/>
+            <a:ext cx="5238750" cy="428625"/>
           </a:xfrm>
           <a:prstGeom xmlns:a="http://schemas.openxmlformats.org/drawingml/2006/main" prst="rect">
             <a:avLst/>
@@ -12896,9 +12835,9 @@
           <a:bodyPr xmlns:a="http://schemas.openxmlformats.org/drawingml/2006/main" lIns="0" tIns="0" rIns="0" bIns="0"/>
           <a:lstStyle xmlns:a="http://schemas.openxmlformats.org/drawingml/2006/main">
             <a:defPPr>
-              <a:defRPr sz="1650">
-                <a:solidFill>
-                  <a:srgbClr val="81796F"/>
+              <a:defRPr sz="2025">
+                <a:solidFill>
+                  <a:srgbClr val="38332E"/>
                 </a:solidFill>
                 <a:latin typeface="Ubuntu Condensed"/>
                 <a:ea typeface="Ubuntu Condensed"/>
@@ -12908,9 +12847,9 @@
           </a:lstStyle>
           <a:p xmlns:a="http://schemas.openxmlformats.org/drawingml/2006/main">
             <a:pPr>
-              <a:defRPr sz="1650">
-                <a:solidFill>
-                  <a:srgbClr val="81796F"/>
+              <a:defRPr sz="2025">
+                <a:solidFill>
+                  <a:srgbClr val="38332E"/>
                 </a:solidFill>
                 <a:latin typeface="Ubuntu Condensed"/>
                 <a:ea typeface="Ubuntu Condensed"/>
@@ -12918,25 +12857,25 @@
               </a:defRPr>
             </a:pPr>
             <a:r>
-              <a:rPr sz="1650">
-                <a:solidFill>
-                  <a:srgbClr val="81796F"/>
+              <a:rPr sz="2025">
+                <a:solidFill>
+                  <a:srgbClr val="38332E"/>
                 </a:solidFill>
                 <a:latin typeface="Ubuntu Condensed"/>
                 <a:ea typeface="Ubuntu Condensed"/>
                 <a:cs typeface="Ubuntu Condensed"/>
               </a:rPr>
-              <a:t>Targets</a:t>
+              <a:t>Click the funnel icon on its toolbar.</a:t>
             </a:r>
           </a:p>
         </p:txBody>
       </p:sp>
       <p:sp>
         <p:nvSpPr>
-          <p:cNvPr id="8" name="">
+          <p:cNvPr id="7" name="">
             <a:extLst xmlns:a="http://schemas.openxmlformats.org/drawingml/2006/main">
               <a:ext uri="{FF2B5EF4-FFF2-40B4-BE49-F238E27FC236}">
-                <a16:creationId xmlns:a16="http://schemas.microsoft.com/office/drawing/2014/main" id="{ECD96BC6-4070-4518-9C64-242EE4AE1F52}"/>
+                <a16:creationId xmlns:a16="http://schemas.microsoft.com/office/drawing/2014/main" id="{B6EC9EB3-4593-466B-89C3-6466A93D2D07}"/>
               </a:ext>
             </a:extLst>
           </p:cNvPr>
@@ -12947,8 +12886,8 @@
         </p:nvSpPr>
         <p:spPr>
           <a:xfrm xmlns:a="http://schemas.openxmlformats.org/drawingml/2006/main">
-            <a:off x="457200" y="3476625"/>
-            <a:ext cx="5238750" cy="381000"/>
+            <a:off x="457200" y="3657600"/>
+            <a:ext cx="5238750" cy="333375"/>
           </a:xfrm>
           <a:prstGeom xmlns:a="http://schemas.openxmlformats.org/drawingml/2006/main" prst="rect">
             <a:avLst/>
@@ -12964,7 +12903,7 @@
             <a:defPPr>
               <a:defRPr sz="2175">
                 <a:solidFill>
-                  <a:srgbClr val="38332E"/>
+                  <a:srgbClr val="B23C50"/>
                 </a:solidFill>
                 <a:latin typeface="Ubuntu Condensed"/>
                 <a:ea typeface="Ubuntu Condensed"/>
@@ -12976,7 +12915,7 @@
             <a:pPr>
               <a:defRPr sz="2175">
                 <a:solidFill>
-                  <a:srgbClr val="38332E"/>
+                  <a:srgbClr val="B23C50"/>
                 </a:solidFill>
                 <a:latin typeface="Ubuntu Condensed"/>
                 <a:ea typeface="Ubuntu Condensed"/>
@@ -12986,23 +12925,23 @@
             <a:r>
               <a:rPr sz="2175">
                 <a:solidFill>
-                  <a:srgbClr val="38332E"/>
+                  <a:srgbClr val="B23C50"/>
                 </a:solidFill>
                 <a:latin typeface="Ubuntu Condensed"/>
                 <a:ea typeface="Ubuntu Condensed"/>
                 <a:cs typeface="Ubuntu Condensed"/>
               </a:rPr>
-              <a:t>Life History + GDP History</a:t>
+              <a:t>3  Select a country</a:t>
             </a:r>
           </a:p>
         </p:txBody>
       </p:sp>
       <p:sp>
         <p:nvSpPr>
-          <p:cNvPr id="9" name="">
+          <p:cNvPr id="8" name="">
             <a:extLst xmlns:a="http://schemas.openxmlformats.org/drawingml/2006/main">
               <a:ext uri="{FF2B5EF4-FFF2-40B4-BE49-F238E27FC236}">
-                <a16:creationId xmlns:a16="http://schemas.microsoft.com/office/drawing/2014/main" id="{6AC856F3-260F-4EB6-AF6A-4A96D29D4DC7}"/>
+                <a16:creationId xmlns:a16="http://schemas.microsoft.com/office/drawing/2014/main" id="{4DE56EAB-8472-4E61-AF8E-1737B3C649D8}"/>
               </a:ext>
             </a:extLst>
           </p:cNvPr>
@@ -13013,272 +12952,8 @@
         </p:nvSpPr>
         <p:spPr>
           <a:xfrm xmlns:a="http://schemas.openxmlformats.org/drawingml/2006/main">
-            <a:off x="457200" y="3895725"/>
-            <a:ext cx="5048250" cy="266700"/>
-          </a:xfrm>
-          <a:prstGeom xmlns:a="http://schemas.openxmlformats.org/drawingml/2006/main" prst="rect">
-            <a:avLst/>
-          </a:prstGeom>
-          <a:noFill xmlns:a="http://schemas.openxmlformats.org/drawingml/2006/main"/>
-          <a:ln xmlns:a="http://schemas.openxmlformats.org/drawingml/2006/main" w="0">
-            <a:noFill/>
-          </a:ln>
-        </p:spPr>
-        <p:txBody>
-          <a:bodyPr xmlns:a="http://schemas.openxmlformats.org/drawingml/2006/main" lIns="0" tIns="0" rIns="0" bIns="0"/>
-          <a:lstStyle xmlns:a="http://schemas.openxmlformats.org/drawingml/2006/main">
-            <a:defPPr>
-              <a:defRPr sz="1650">
-                <a:solidFill>
-                  <a:srgbClr val="81796F"/>
-                </a:solidFill>
-                <a:latin typeface="Ubuntu Condensed"/>
-                <a:ea typeface="Ubuntu Condensed"/>
-                <a:cs typeface="Ubuntu Condensed"/>
-              </a:defRPr>
-            </a:defPPr>
-          </a:lstStyle>
-          <a:p xmlns:a="http://schemas.openxmlformats.org/drawingml/2006/main">
-            <a:pPr>
-              <a:defRPr sz="1650">
-                <a:solidFill>
-                  <a:srgbClr val="81796F"/>
-                </a:solidFill>
-                <a:latin typeface="Ubuntu Condensed"/>
-                <a:ea typeface="Ubuntu Condensed"/>
-                <a:cs typeface="Ubuntu Condensed"/>
-              </a:defRPr>
-            </a:pPr>
-            <a:r>
-              <a:rPr sz="1650">
-                <a:solidFill>
-                  <a:srgbClr val="81796F"/>
-                </a:solidFill>
-                <a:latin typeface="Ubuntu Condensed"/>
-                <a:ea typeface="Ubuntu Condensed"/>
-                <a:cs typeface="Ubuntu Condensed"/>
-              </a:rPr>
-              <a:t>Selected Fields</a:t>
-            </a:r>
-          </a:p>
-        </p:txBody>
-      </p:sp>
-      <p:sp>
-        <p:nvSpPr>
-          <p:cNvPr id="10" name="">
-            <a:extLst xmlns:a="http://schemas.openxmlformats.org/drawingml/2006/main">
-              <a:ext uri="{FF2B5EF4-FFF2-40B4-BE49-F238E27FC236}">
-                <a16:creationId xmlns:a16="http://schemas.microsoft.com/office/drawing/2014/main" id="{236E3D55-D70B-4293-98DC-683573F0B7AE}"/>
-              </a:ext>
-            </a:extLst>
-          </p:cNvPr>
-          <p:cNvSpPr>
-            <a:spLocks xmlns:a="http://schemas.openxmlformats.org/drawingml/2006/main" noGrp="1"/>
-          </p:cNvSpPr>
-          <p:nvPr/>
-        </p:nvSpPr>
-        <p:spPr>
-          <a:xfrm xmlns:a="http://schemas.openxmlformats.org/drawingml/2006/main">
-            <a:off x="457200" y="4191000"/>
-            <a:ext cx="5238750" cy="381000"/>
-          </a:xfrm>
-          <a:prstGeom xmlns:a="http://schemas.openxmlformats.org/drawingml/2006/main" prst="rect">
-            <a:avLst/>
-          </a:prstGeom>
-          <a:noFill xmlns:a="http://schemas.openxmlformats.org/drawingml/2006/main"/>
-          <a:ln xmlns:a="http://schemas.openxmlformats.org/drawingml/2006/main" w="0">
-            <a:noFill/>
-          </a:ln>
-        </p:spPr>
-        <p:txBody>
-          <a:bodyPr xmlns:a="http://schemas.openxmlformats.org/drawingml/2006/main" lIns="0" tIns="0" rIns="0" bIns="0"/>
-          <a:lstStyle xmlns:a="http://schemas.openxmlformats.org/drawingml/2006/main">
-            <a:defPPr>
-              <a:defRPr sz="2175">
-                <a:solidFill>
-                  <a:srgbClr val="B23C50"/>
-                </a:solidFill>
-                <a:latin typeface="Ubuntu Condensed"/>
-                <a:ea typeface="Ubuntu Condensed"/>
-                <a:cs typeface="Ubuntu Condensed"/>
-              </a:defRPr>
-            </a:defPPr>
-          </a:lstStyle>
-          <a:p xmlns:a="http://schemas.openxmlformats.org/drawingml/2006/main">
-            <a:pPr>
-              <a:defRPr sz="2175">
-                <a:solidFill>
-                  <a:srgbClr val="B23C50"/>
-                </a:solidFill>
-                <a:latin typeface="Ubuntu Condensed"/>
-                <a:ea typeface="Ubuntu Condensed"/>
-                <a:cs typeface="Ubuntu Condensed"/>
-              </a:defRPr>
-            </a:pPr>
-            <a:r>
-              <a:rPr sz="2175">
-                <a:solidFill>
-                  <a:srgbClr val="B23C50"/>
-                </a:solidFill>
-                <a:latin typeface="Ubuntu Condensed"/>
-                <a:ea typeface="Ubuntu Condensed"/>
-                <a:cs typeface="Ubuntu Condensed"/>
-              </a:rPr>
-              <a:t>Country → Country</a:t>
-            </a:r>
-          </a:p>
-        </p:txBody>
-      </p:sp>
-      <p:sp>
-        <p:nvSpPr>
-          <p:cNvPr id="11" name="">
-            <a:extLst xmlns:a="http://schemas.openxmlformats.org/drawingml/2006/main">
-              <a:ext uri="{FF2B5EF4-FFF2-40B4-BE49-F238E27FC236}">
-                <a16:creationId xmlns:a16="http://schemas.microsoft.com/office/drawing/2014/main" id="{64C6ED73-2A4E-47D0-9957-75B112B6BDEC}"/>
-              </a:ext>
-            </a:extLst>
-          </p:cNvPr>
-          <p:cNvSpPr>
-            <a:spLocks xmlns:a="http://schemas.openxmlformats.org/drawingml/2006/main" noGrp="1"/>
-          </p:cNvSpPr>
-          <p:nvPr/>
-        </p:nvSpPr>
-        <p:spPr>
-          <a:xfrm xmlns:a="http://schemas.openxmlformats.org/drawingml/2006/main">
-            <a:off x="457200" y="4610100"/>
-            <a:ext cx="5048250" cy="266700"/>
-          </a:xfrm>
-          <a:prstGeom xmlns:a="http://schemas.openxmlformats.org/drawingml/2006/main" prst="rect">
-            <a:avLst/>
-          </a:prstGeom>
-          <a:noFill xmlns:a="http://schemas.openxmlformats.org/drawingml/2006/main"/>
-          <a:ln xmlns:a="http://schemas.openxmlformats.org/drawingml/2006/main" w="0">
-            <a:noFill/>
-          </a:ln>
-        </p:spPr>
-        <p:txBody>
-          <a:bodyPr xmlns:a="http://schemas.openxmlformats.org/drawingml/2006/main" lIns="0" tIns="0" rIns="0" bIns="0"/>
-          <a:lstStyle xmlns:a="http://schemas.openxmlformats.org/drawingml/2006/main">
-            <a:defPPr>
-              <a:defRPr sz="1650">
-                <a:solidFill>
-                  <a:srgbClr val="81796F"/>
-                </a:solidFill>
-                <a:latin typeface="Ubuntu Condensed"/>
-                <a:ea typeface="Ubuntu Condensed"/>
-                <a:cs typeface="Ubuntu Condensed"/>
-              </a:defRPr>
-            </a:defPPr>
-          </a:lstStyle>
-          <a:p xmlns:a="http://schemas.openxmlformats.org/drawingml/2006/main">
-            <a:pPr>
-              <a:defRPr sz="1650">
-                <a:solidFill>
-                  <a:srgbClr val="81796F"/>
-                </a:solidFill>
-                <a:latin typeface="Ubuntu Condensed"/>
-                <a:ea typeface="Ubuntu Condensed"/>
-                <a:cs typeface="Ubuntu Condensed"/>
-              </a:defRPr>
-            </a:pPr>
-            <a:r>
-              <a:rPr sz="1650">
-                <a:solidFill>
-                  <a:srgbClr val="81796F"/>
-                </a:solidFill>
-                <a:latin typeface="Ubuntu Condensed"/>
-                <a:ea typeface="Ubuntu Condensed"/>
-                <a:cs typeface="Ubuntu Condensed"/>
-              </a:rPr>
-              <a:t>Clear selection</a:t>
-            </a:r>
-          </a:p>
-        </p:txBody>
-      </p:sp>
-      <p:sp>
-        <p:nvSpPr>
-          <p:cNvPr id="12" name="">
-            <a:extLst xmlns:a="http://schemas.openxmlformats.org/drawingml/2006/main">
-              <a:ext uri="{FF2B5EF4-FFF2-40B4-BE49-F238E27FC236}">
-                <a16:creationId xmlns:a16="http://schemas.microsoft.com/office/drawing/2014/main" id="{3E59FF9E-A28C-48C4-94F4-D187E7B6A9AF}"/>
-              </a:ext>
-            </a:extLst>
-          </p:cNvPr>
-          <p:cNvSpPr>
-            <a:spLocks xmlns:a="http://schemas.openxmlformats.org/drawingml/2006/main" noGrp="1"/>
-          </p:cNvSpPr>
-          <p:nvPr/>
-        </p:nvSpPr>
-        <p:spPr>
-          <a:xfrm xmlns:a="http://schemas.openxmlformats.org/drawingml/2006/main">
-            <a:off x="457200" y="4905375"/>
-            <a:ext cx="5238750" cy="381000"/>
-          </a:xfrm>
-          <a:prstGeom xmlns:a="http://schemas.openxmlformats.org/drawingml/2006/main" prst="rect">
-            <a:avLst/>
-          </a:prstGeom>
-          <a:noFill xmlns:a="http://schemas.openxmlformats.org/drawingml/2006/main"/>
-          <a:ln xmlns:a="http://schemas.openxmlformats.org/drawingml/2006/main" w="0">
-            <a:noFill/>
-          </a:ln>
-        </p:spPr>
-        <p:txBody>
-          <a:bodyPr xmlns:a="http://schemas.openxmlformats.org/drawingml/2006/main" lIns="0" tIns="0" rIns="0" bIns="0"/>
-          <a:lstStyle xmlns:a="http://schemas.openxmlformats.org/drawingml/2006/main">
-            <a:defPPr>
-              <a:defRPr sz="2175">
-                <a:solidFill>
-                  <a:srgbClr val="38332E"/>
-                </a:solidFill>
-                <a:latin typeface="Ubuntu Condensed"/>
-                <a:ea typeface="Ubuntu Condensed"/>
-                <a:cs typeface="Ubuntu Condensed"/>
-              </a:defRPr>
-            </a:defPPr>
-          </a:lstStyle>
-          <a:p xmlns:a="http://schemas.openxmlformats.org/drawingml/2006/main">
-            <a:pPr>
-              <a:defRPr sz="2175">
-                <a:solidFill>
-                  <a:srgbClr val="38332E"/>
-                </a:solidFill>
-                <a:latin typeface="Ubuntu Condensed"/>
-                <a:ea typeface="Ubuntu Condensed"/>
-                <a:cs typeface="Ubuntu Condensed"/>
-              </a:defRPr>
-            </a:pPr>
-            <a:r>
-              <a:rPr sz="2175">
-                <a:solidFill>
-                  <a:srgbClr val="38332E"/>
-                </a:solidFill>
-                <a:latin typeface="Ubuntu Condensed"/>
-                <a:ea typeface="Ubuntu Condensed"/>
-                <a:cs typeface="Ubuntu Condensed"/>
-              </a:rPr>
-              <a:t>Show all values</a:t>
-            </a:r>
-          </a:p>
-        </p:txBody>
-      </p:sp>
-      <p:sp>
-        <p:nvSpPr>
-          <p:cNvPr id="13" name="">
-            <a:extLst xmlns:a="http://schemas.openxmlformats.org/drawingml/2006/main">
-              <a:ext uri="{FF2B5EF4-FFF2-40B4-BE49-F238E27FC236}">
-                <a16:creationId xmlns:a16="http://schemas.microsoft.com/office/drawing/2014/main" id="{A91CE2D0-6593-43CE-9835-5E6A36F214FC}"/>
-              </a:ext>
-            </a:extLst>
-          </p:cNvPr>
-          <p:cNvSpPr>
-            <a:spLocks xmlns:a="http://schemas.openxmlformats.org/drawingml/2006/main" noGrp="1"/>
-          </p:cNvSpPr>
-          <p:nvPr/>
-        </p:nvSpPr>
-        <p:spPr>
-          <a:xfrm xmlns:a="http://schemas.openxmlformats.org/drawingml/2006/main">
-            <a:off x="457200" y="5838825"/>
-            <a:ext cx="5238750" cy="571500"/>
+            <a:off x="457200" y="4048125"/>
+            <a:ext cx="5238750" cy="428625"/>
           </a:xfrm>
           <a:prstGeom xmlns:a="http://schemas.openxmlformats.org/drawingml/2006/main" prst="rect">
             <a:avLst/>
@@ -13294,7 +12969,7 @@
             <a:defPPr>
               <a:defRPr sz="2025">
                 <a:solidFill>
-                  <a:srgbClr val="B23C50"/>
+                  <a:srgbClr val="38332E"/>
                 </a:solidFill>
                 <a:latin typeface="Ubuntu Condensed"/>
                 <a:ea typeface="Ubuntu Condensed"/>
@@ -13306,7 +12981,7 @@
             <a:pPr>
               <a:defRPr sz="2025">
                 <a:solidFill>
-                  <a:srgbClr val="B23C50"/>
+                  <a:srgbClr val="38332E"/>
                 </a:solidFill>
                 <a:latin typeface="Ubuntu Condensed"/>
                 <a:ea typeface="Ubuntu Condensed"/>
@@ -13316,23 +12991,201 @@
             <a:r>
               <a:rPr sz="2025">
                 <a:solidFill>
-                  <a:srgbClr val="B23C50"/>
+                  <a:srgbClr val="38332E"/>
                 </a:solidFill>
                 <a:latin typeface="Ubuntu Condensed"/>
                 <a:ea typeface="Ubuntu Condensed"/>
                 <a:cs typeface="Ubuntu Condensed"/>
               </a:rPr>
-              <a:t>Do not pass Year to the history sheets.</a:t>
+              <a:t>Click Japan, then try India.</a:t>
             </a:r>
           </a:p>
         </p:txBody>
       </p:sp>
       <p:sp>
         <p:nvSpPr>
-          <p:cNvPr id="14" name="">
+          <p:cNvPr id="9" name="">
             <a:extLst xmlns:a="http://schemas.openxmlformats.org/drawingml/2006/main">
               <a:ext uri="{FF2B5EF4-FFF2-40B4-BE49-F238E27FC236}">
-                <a16:creationId xmlns:a16="http://schemas.microsoft.com/office/drawing/2014/main" id="{0DBC5C7A-5E25-401D-8A91-2E3C67142370}"/>
+                <a16:creationId xmlns:a16="http://schemas.microsoft.com/office/drawing/2014/main" id="{01F0BC9E-756B-487D-BFD8-450371A801B9}"/>
+              </a:ext>
+            </a:extLst>
+          </p:cNvPr>
+          <p:cNvSpPr>
+            <a:spLocks xmlns:a="http://schemas.openxmlformats.org/drawingml/2006/main" noGrp="1"/>
+          </p:cNvSpPr>
+          <p:nvPr/>
+        </p:nvSpPr>
+        <p:spPr>
+          <a:xfrm xmlns:a="http://schemas.openxmlformats.org/drawingml/2006/main">
+            <a:off x="457200" y="4857750"/>
+            <a:ext cx="5238750" cy="333375"/>
+          </a:xfrm>
+          <a:prstGeom xmlns:a="http://schemas.openxmlformats.org/drawingml/2006/main" prst="rect">
+            <a:avLst/>
+          </a:prstGeom>
+          <a:noFill xmlns:a="http://schemas.openxmlformats.org/drawingml/2006/main"/>
+          <a:ln xmlns:a="http://schemas.openxmlformats.org/drawingml/2006/main" w="0">
+            <a:noFill/>
+          </a:ln>
+        </p:spPr>
+        <p:txBody>
+          <a:bodyPr xmlns:a="http://schemas.openxmlformats.org/drawingml/2006/main" lIns="0" tIns="0" rIns="0" bIns="0"/>
+          <a:lstStyle xmlns:a="http://schemas.openxmlformats.org/drawingml/2006/main">
+            <a:defPPr>
+              <a:defRPr sz="1875">
+                <a:solidFill>
+                  <a:srgbClr val="B23C50"/>
+                </a:solidFill>
+                <a:latin typeface="Ubuntu Condensed"/>
+                <a:ea typeface="Ubuntu Condensed"/>
+                <a:cs typeface="Ubuntu Condensed"/>
+              </a:defRPr>
+            </a:defPPr>
+          </a:lstStyle>
+          <a:p xmlns:a="http://schemas.openxmlformats.org/drawingml/2006/main">
+            <a:pPr>
+              <a:defRPr sz="1875">
+                <a:solidFill>
+                  <a:srgbClr val="B23C50"/>
+                </a:solidFill>
+                <a:latin typeface="Ubuntu Condensed"/>
+                <a:ea typeface="Ubuntu Condensed"/>
+                <a:cs typeface="Ubuntu Condensed"/>
+              </a:defRPr>
+            </a:pPr>
+            <a:r>
+              <a:rPr sz="1875">
+                <a:solidFill>
+                  <a:srgbClr val="B23C50"/>
+                </a:solidFill>
+                <a:latin typeface="Ubuntu Condensed"/>
+                <a:ea typeface="Ubuntu Condensed"/>
+                <a:cs typeface="Ubuntu Condensed"/>
+              </a:rPr>
+              <a:t>If a history collapses to 2020:</a:t>
+            </a:r>
+          </a:p>
+        </p:txBody>
+      </p:sp>
+      <p:sp>
+        <p:nvSpPr>
+          <p:cNvPr id="10" name="">
+            <a:extLst xmlns:a="http://schemas.openxmlformats.org/drawingml/2006/main">
+              <a:ext uri="{FF2B5EF4-FFF2-40B4-BE49-F238E27FC236}">
+                <a16:creationId xmlns:a16="http://schemas.microsoft.com/office/drawing/2014/main" id="{A96EFA78-ED6B-40BE-91FB-0CBF67C9C6D9}"/>
+              </a:ext>
+            </a:extLst>
+          </p:cNvPr>
+          <p:cNvSpPr>
+            <a:spLocks xmlns:a="http://schemas.openxmlformats.org/drawingml/2006/main" noGrp="1"/>
+          </p:cNvSpPr>
+          <p:nvPr/>
+        </p:nvSpPr>
+        <p:spPr>
+          <a:xfrm xmlns:a="http://schemas.openxmlformats.org/drawingml/2006/main">
+            <a:off x="457200" y="5267325"/>
+            <a:ext cx="5238750" cy="1047750"/>
+          </a:xfrm>
+          <a:prstGeom xmlns:a="http://schemas.openxmlformats.org/drawingml/2006/main" prst="rect">
+            <a:avLst/>
+          </a:prstGeom>
+          <a:noFill xmlns:a="http://schemas.openxmlformats.org/drawingml/2006/main"/>
+          <a:ln xmlns:a="http://schemas.openxmlformats.org/drawingml/2006/main" w="0">
+            <a:noFill/>
+          </a:ln>
+        </p:spPr>
+        <p:txBody>
+          <a:bodyPr xmlns:a="http://schemas.openxmlformats.org/drawingml/2006/main" lIns="0" tIns="0" rIns="0" bIns="0"/>
+          <a:lstStyle xmlns:a="http://schemas.openxmlformats.org/drawingml/2006/main">
+            <a:defPPr>
+              <a:defRPr sz="1725">
+                <a:solidFill>
+                  <a:srgbClr val="81796F"/>
+                </a:solidFill>
+                <a:latin typeface="Ubuntu Condensed"/>
+                <a:ea typeface="Ubuntu Condensed"/>
+                <a:cs typeface="Ubuntu Condensed"/>
+              </a:defRPr>
+            </a:defPPr>
+          </a:lstStyle>
+          <a:p xmlns:a="http://schemas.openxmlformats.org/drawingml/2006/main">
+            <a:pPr>
+              <a:defRPr sz="1725">
+                <a:solidFill>
+                  <a:srgbClr val="81796F"/>
+                </a:solidFill>
+                <a:latin typeface="Ubuntu Condensed"/>
+                <a:ea typeface="Ubuntu Condensed"/>
+                <a:cs typeface="Ubuntu Condensed"/>
+              </a:defRPr>
+            </a:pPr>
+            <a:r>
+              <a:rPr sz="1725">
+                <a:solidFill>
+                  <a:srgbClr val="81796F"/>
+                </a:solidFill>
+                <a:latin typeface="Ubuntu Condensed"/>
+                <a:ea typeface="Ubuntu Condensed"/>
+                <a:cs typeface="Ubuntu Condensed"/>
+              </a:rPr>
+              <a:t>Dashboard &gt; Actions: edit the generated filter.</a:t>
+            </a:r>
+          </a:p>
+          <a:p xmlns:a="http://schemas.openxmlformats.org/drawingml/2006/main">
+            <a:pPr>
+              <a:defRPr sz="1725">
+                <a:solidFill>
+                  <a:srgbClr val="81796F"/>
+                </a:solidFill>
+                <a:latin typeface="Ubuntu Condensed"/>
+                <a:ea typeface="Ubuntu Condensed"/>
+                <a:cs typeface="Ubuntu Condensed"/>
+              </a:defRPr>
+            </a:pPr>
+            <a:r>
+              <a:rPr sz="1725">
+                <a:solidFill>
+                  <a:srgbClr val="81796F"/>
+                </a:solidFill>
+                <a:latin typeface="Ubuntu Condensed"/>
+                <a:ea typeface="Ubuntu Condensed"/>
+                <a:cs typeface="Ubuntu Condensed"/>
+              </a:rPr>
+              <a:t>Selected Fields: Country → Country only</a:t>
+            </a:r>
+          </a:p>
+          <a:p xmlns:a="http://schemas.openxmlformats.org/drawingml/2006/main">
+            <a:pPr>
+              <a:defRPr sz="1725">
+                <a:solidFill>
+                  <a:srgbClr val="81796F"/>
+                </a:solidFill>
+                <a:latin typeface="Ubuntu Condensed"/>
+                <a:ea typeface="Ubuntu Condensed"/>
+                <a:cs typeface="Ubuntu Condensed"/>
+              </a:defRPr>
+            </a:pPr>
+            <a:r>
+              <a:rPr sz="1725">
+                <a:solidFill>
+                  <a:srgbClr val="81796F"/>
+                </a:solidFill>
+                <a:latin typeface="Ubuntu Condensed"/>
+                <a:ea typeface="Ubuntu Condensed"/>
+                <a:cs typeface="Ubuntu Condensed"/>
+              </a:rPr>
+              <a:t>Clear selection: Show all values</a:t>
+            </a:r>
+          </a:p>
+        </p:txBody>
+      </p:sp>
+      <p:sp>
+        <p:nvSpPr>
+          <p:cNvPr id="11" name="">
+            <a:extLst xmlns:a="http://schemas.openxmlformats.org/drawingml/2006/main">
+              <a:ext uri="{FF2B5EF4-FFF2-40B4-BE49-F238E27FC236}">
+                <a16:creationId xmlns:a16="http://schemas.microsoft.com/office/drawing/2014/main" id="{0DA9877E-BE88-4623-884E-178C49F5F18D}"/>
               </a:ext>
             </a:extLst>
           </p:cNvPr>
@@ -13395,10 +13248,10 @@
       </p:sp>
       <p:graphicFrame>
         <p:nvGraphicFramePr>
-          <p:cNvPr id="15" name="Chart">
+          <p:cNvPr id="12" name="Chart">
             <a:extLst xmlns:a="http://schemas.openxmlformats.org/drawingml/2006/main">
               <a:ext uri="{FF2B5EF4-FFF2-40B4-BE49-F238E27FC236}">
-                <a16:creationId xmlns:a16="http://schemas.microsoft.com/office/drawing/2014/main" id="{FA3D24A1-DACE-40F1-92D9-88BE783EDC9A}"/>
+                <a16:creationId xmlns:a16="http://schemas.microsoft.com/office/drawing/2014/main" id="{96A4A486-5C4D-4875-A518-9F7E600661F2}"/>
               </a:ext>
             </a:extLst>
           </p:cNvPr>
@@ -13411,16 +13264,16 @@
         </p:xfrm>
         <a:graphic xmlns:a="http://schemas.openxmlformats.org/drawingml/2006/main">
           <a:graphicData uri="http://schemas.openxmlformats.org/drawingml/2006/chart">
-            <c:chart xmlns:r="http://schemas.openxmlformats.org/officeDocument/2006/relationships" xmlns:c="http://schemas.openxmlformats.org/drawingml/2006/chart" r:id="R2df22954b45440e0"/>
+            <c:chart xmlns:r="http://schemas.openxmlformats.org/officeDocument/2006/relationships" xmlns:c="http://schemas.openxmlformats.org/drawingml/2006/chart" r:id="Rfd0917d170854f8e"/>
           </a:graphicData>
         </a:graphic>
       </p:graphicFrame>
       <p:sp>
         <p:nvSpPr>
-          <p:cNvPr id="16" name="">
+          <p:cNvPr id="13" name="">
             <a:extLst xmlns:a="http://schemas.openxmlformats.org/drawingml/2006/main">
               <a:ext uri="{FF2B5EF4-FFF2-40B4-BE49-F238E27FC236}">
-                <a16:creationId xmlns:a16="http://schemas.microsoft.com/office/drawing/2014/main" id="{F38BAE88-10A1-4B0D-B052-C674379DE9A8}"/>
+                <a16:creationId xmlns:a16="http://schemas.microsoft.com/office/drawing/2014/main" id="{3826C42E-0E16-4A41-98E0-FD65FC25E1A2}"/>
               </a:ext>
             </a:extLst>
           </p:cNvPr>
@@ -13483,10 +13336,10 @@
       </p:sp>
       <p:sp>
         <p:nvSpPr>
-          <p:cNvPr id="17" name="">
+          <p:cNvPr id="14" name="">
             <a:extLst xmlns:a="http://schemas.openxmlformats.org/drawingml/2006/main">
               <a:ext uri="{FF2B5EF4-FFF2-40B4-BE49-F238E27FC236}">
-                <a16:creationId xmlns:a16="http://schemas.microsoft.com/office/drawing/2014/main" id="{ACBEA023-3979-419A-B9F7-06CFA99257AF}"/>
+                <a16:creationId xmlns:a16="http://schemas.microsoft.com/office/drawing/2014/main" id="{DE89A056-A4BF-4E0B-96E8-CA2C43ED11F2}"/>
               </a:ext>
             </a:extLst>
           </p:cNvPr>
@@ -13549,10 +13402,10 @@
       </p:sp>
       <p:sp>
         <p:nvSpPr>
-          <p:cNvPr id="18" name="">
+          <p:cNvPr id="15" name="">
             <a:extLst xmlns:a="http://schemas.openxmlformats.org/drawingml/2006/main">
               <a:ext uri="{FF2B5EF4-FFF2-40B4-BE49-F238E27FC236}">
-                <a16:creationId xmlns:a16="http://schemas.microsoft.com/office/drawing/2014/main" id="{4F37BF22-00AF-4D1A-ADF0-3DFFFDF9CE78}"/>
+                <a16:creationId xmlns:a16="http://schemas.microsoft.com/office/drawing/2014/main" id="{A8F38249-80E1-4BF8-BE4C-92361160C39A}"/>
               </a:ext>
             </a:extLst>
           </p:cNvPr>
@@ -13615,10 +13468,10 @@
       </p:sp>
       <p:graphicFrame>
         <p:nvGraphicFramePr>
-          <p:cNvPr id="19" name="Chart">
+          <p:cNvPr id="16" name="Chart">
             <a:extLst xmlns:a="http://schemas.openxmlformats.org/drawingml/2006/main">
               <a:ext uri="{FF2B5EF4-FFF2-40B4-BE49-F238E27FC236}">
-                <a16:creationId xmlns:a16="http://schemas.microsoft.com/office/drawing/2014/main" id="{8D0668DF-A343-4AAB-9810-32673D0B3F2C}"/>
+                <a16:creationId xmlns:a16="http://schemas.microsoft.com/office/drawing/2014/main" id="{DC9CF416-1236-423B-827D-C9FC17A01A76}"/>
               </a:ext>
             </a:extLst>
           </p:cNvPr>
@@ -13631,16 +13484,16 @@
         </p:xfrm>
         <a:graphic xmlns:a="http://schemas.openxmlformats.org/drawingml/2006/main">
           <a:graphicData uri="http://schemas.openxmlformats.org/drawingml/2006/chart">
-            <c:chart xmlns:r="http://schemas.openxmlformats.org/officeDocument/2006/relationships" xmlns:c="http://schemas.openxmlformats.org/drawingml/2006/chart" r:id="R1f8206adc9104131"/>
+            <c:chart xmlns:r="http://schemas.openxmlformats.org/officeDocument/2006/relationships" xmlns:c="http://schemas.openxmlformats.org/drawingml/2006/chart" r:id="R5f07b49da28840f4"/>
           </a:graphicData>
         </a:graphic>
       </p:graphicFrame>
       <p:sp>
         <p:nvSpPr>
-          <p:cNvPr id="20" name="">
+          <p:cNvPr id="17" name="">
             <a:extLst xmlns:a="http://schemas.openxmlformats.org/drawingml/2006/main">
               <a:ext uri="{FF2B5EF4-FFF2-40B4-BE49-F238E27FC236}">
-                <a16:creationId xmlns:a16="http://schemas.microsoft.com/office/drawing/2014/main" id="{6633D29A-B85A-46A9-BA7B-F89D018994F8}"/>
+                <a16:creationId xmlns:a16="http://schemas.microsoft.com/office/drawing/2014/main" id="{B79909F4-9941-49BB-9862-EBA9DF759195}"/>
               </a:ext>
             </a:extLst>
           </p:cNvPr>
@@ -13703,10 +13556,10 @@
       </p:sp>
       <p:sp>
         <p:nvSpPr>
-          <p:cNvPr id="21" name="">
+          <p:cNvPr id="18" name="">
             <a:extLst xmlns:a="http://schemas.openxmlformats.org/drawingml/2006/main">
               <a:ext uri="{FF2B5EF4-FFF2-40B4-BE49-F238E27FC236}">
-                <a16:creationId xmlns:a16="http://schemas.microsoft.com/office/drawing/2014/main" id="{79F3DD77-004E-4375-93E8-627E424208C1}"/>
+                <a16:creationId xmlns:a16="http://schemas.microsoft.com/office/drawing/2014/main" id="{24603D99-56AE-45C6-B500-37C0206C6324}"/>
               </a:ext>
             </a:extLst>
           </p:cNvPr>
@@ -13769,10 +13622,10 @@
       </p:sp>
       <p:sp>
         <p:nvSpPr>
-          <p:cNvPr id="22" name="">
+          <p:cNvPr id="19" name="">
             <a:extLst xmlns:a="http://schemas.openxmlformats.org/drawingml/2006/main">
               <a:ext uri="{FF2B5EF4-FFF2-40B4-BE49-F238E27FC236}">
-                <a16:creationId xmlns:a16="http://schemas.microsoft.com/office/drawing/2014/main" id="{A2507981-BFCA-4722-8E10-75D328F15AD8}"/>
+                <a16:creationId xmlns:a16="http://schemas.microsoft.com/office/drawing/2014/main" id="{656DCA50-2205-4355-A4FE-D02EB9A0CE2C}"/>
               </a:ext>
             </a:extLst>
           </p:cNvPr>
@@ -13836,7 +13689,7 @@
     </p:spTree>
     <p:extLst>
       <p:ext uri="{BB962C8B-B14F-4D97-AF65-F5344CB8AC3E}">
-        <p14:creationId xmlns:p14="http://schemas.microsoft.com/office/powerpoint/2010/main" val="18119054"/>
+        <p14:creationId xmlns:p14="http://schemas.microsoft.com/office/powerpoint/2010/main" val="742562496"/>
       </p:ext>
     </p:extLst>
   </p:cSld>
@@ -13867,7 +13720,7 @@
           <p:cNvPr id="14" name="">
             <a:extLst xmlns:a="http://schemas.openxmlformats.org/drawingml/2006/main">
               <a:ext uri="{FF2B5EF4-FFF2-40B4-BE49-F238E27FC236}">
-                <a16:creationId xmlns:a16="http://schemas.microsoft.com/office/drawing/2014/main" id="{8427FA3D-D72F-4C9D-845B-A8E0D9045D25}"/>
+                <a16:creationId xmlns:a16="http://schemas.microsoft.com/office/drawing/2014/main" id="{892C9D5F-73CC-4524-8FF3-E2C80ABCC86A}"/>
               </a:ext>
             </a:extLst>
           </p:cNvPr>
@@ -13933,7 +13786,7 @@
           <p:cNvPr id="2" name="">
             <a:extLst xmlns:a="http://schemas.openxmlformats.org/drawingml/2006/main">
               <a:ext uri="{FF2B5EF4-FFF2-40B4-BE49-F238E27FC236}">
-                <a16:creationId xmlns:a16="http://schemas.microsoft.com/office/drawing/2014/main" id="{05A88776-CEE5-4B1A-B915-17CFA517708D}"/>
+                <a16:creationId xmlns:a16="http://schemas.microsoft.com/office/drawing/2014/main" id="{3FBD6F58-61C6-400B-A6F2-1EB3A1C21F5F}"/>
               </a:ext>
             </a:extLst>
           </p:cNvPr>
@@ -13999,7 +13852,7 @@
           <p:cNvPr id="3" name="">
             <a:extLst xmlns:a="http://schemas.openxmlformats.org/drawingml/2006/main">
               <a:ext uri="{FF2B5EF4-FFF2-40B4-BE49-F238E27FC236}">
-                <a16:creationId xmlns:a16="http://schemas.microsoft.com/office/drawing/2014/main" id="{A4BA0FC3-16F3-4CC5-8618-771A4B1E26DD}"/>
+                <a16:creationId xmlns:a16="http://schemas.microsoft.com/office/drawing/2014/main" id="{B9E240B3-5610-435E-9549-F664E869C7B3}"/>
               </a:ext>
             </a:extLst>
           </p:cNvPr>
@@ -14065,7 +13918,7 @@
           <p:cNvPr id="4" name="">
             <a:extLst xmlns:a="http://schemas.openxmlformats.org/drawingml/2006/main">
               <a:ext uri="{FF2B5EF4-FFF2-40B4-BE49-F238E27FC236}">
-                <a16:creationId xmlns:a16="http://schemas.microsoft.com/office/drawing/2014/main" id="{EAC5D4C1-1BF9-40BF-B293-87DF9B3BA965}"/>
+                <a16:creationId xmlns:a16="http://schemas.microsoft.com/office/drawing/2014/main" id="{74AFFE53-02F2-4C59-A867-0EAFC1E68447}"/>
               </a:ext>
             </a:extLst>
           </p:cNvPr>
@@ -14131,7 +13984,7 @@
           <p:cNvPr id="5" name="">
             <a:extLst xmlns:a="http://schemas.openxmlformats.org/drawingml/2006/main">
               <a:ext uri="{FF2B5EF4-FFF2-40B4-BE49-F238E27FC236}">
-                <a16:creationId xmlns:a16="http://schemas.microsoft.com/office/drawing/2014/main" id="{B7CF8607-45A4-420A-BFB8-2A16E160AB12}"/>
+                <a16:creationId xmlns:a16="http://schemas.microsoft.com/office/drawing/2014/main" id="{0B9A1D11-19D2-425B-A671-ED35EBD74AB3}"/>
               </a:ext>
             </a:extLst>
           </p:cNvPr>
@@ -14197,7 +14050,7 @@
           <p:cNvPr id="6" name="">
             <a:extLst xmlns:a="http://schemas.openxmlformats.org/drawingml/2006/main">
               <a:ext uri="{FF2B5EF4-FFF2-40B4-BE49-F238E27FC236}">
-                <a16:creationId xmlns:a16="http://schemas.microsoft.com/office/drawing/2014/main" id="{E13BCFFE-FFC2-4E73-BE53-87943556BC8C}"/>
+                <a16:creationId xmlns:a16="http://schemas.microsoft.com/office/drawing/2014/main" id="{7FA5549D-5124-4A89-BB45-4162D49A5356}"/>
               </a:ext>
             </a:extLst>
           </p:cNvPr>
@@ -14263,7 +14116,7 @@
           <p:cNvPr id="7" name="">
             <a:extLst xmlns:a="http://schemas.openxmlformats.org/drawingml/2006/main">
               <a:ext uri="{FF2B5EF4-FFF2-40B4-BE49-F238E27FC236}">
-                <a16:creationId xmlns:a16="http://schemas.microsoft.com/office/drawing/2014/main" id="{2E9BFEA4-B196-4D59-8328-DC5B189CE25C}"/>
+                <a16:creationId xmlns:a16="http://schemas.microsoft.com/office/drawing/2014/main" id="{750CE3EE-F2CF-449D-B3C9-87B9162D85DB}"/>
               </a:ext>
             </a:extLst>
           </p:cNvPr>
@@ -14329,7 +14182,7 @@
           <p:cNvPr id="8" name="">
             <a:extLst xmlns:a="http://schemas.openxmlformats.org/drawingml/2006/main">
               <a:ext uri="{FF2B5EF4-FFF2-40B4-BE49-F238E27FC236}">
-                <a16:creationId xmlns:a16="http://schemas.microsoft.com/office/drawing/2014/main" id="{74B30C78-DE17-45D7-94B1-2E3C78213B29}"/>
+                <a16:creationId xmlns:a16="http://schemas.microsoft.com/office/drawing/2014/main" id="{CA40AA29-528F-4F5B-92DE-AA398A4DCD06}"/>
               </a:ext>
             </a:extLst>
           </p:cNvPr>
@@ -14395,7 +14248,7 @@
           <p:cNvPr id="9" name="">
             <a:extLst xmlns:a="http://schemas.openxmlformats.org/drawingml/2006/main">
               <a:ext uri="{FF2B5EF4-FFF2-40B4-BE49-F238E27FC236}">
-                <a16:creationId xmlns:a16="http://schemas.microsoft.com/office/drawing/2014/main" id="{BB9C6088-EFDA-4D79-A0A6-41406E2117C3}"/>
+                <a16:creationId xmlns:a16="http://schemas.microsoft.com/office/drawing/2014/main" id="{051632A3-4936-4771-8218-0EB1949FAEEC}"/>
               </a:ext>
             </a:extLst>
           </p:cNvPr>
@@ -14461,7 +14314,7 @@
           <p:cNvPr id="10" name="">
             <a:extLst xmlns:a="http://schemas.openxmlformats.org/drawingml/2006/main">
               <a:ext uri="{FF2B5EF4-FFF2-40B4-BE49-F238E27FC236}">
-                <a16:creationId xmlns:a16="http://schemas.microsoft.com/office/drawing/2014/main" id="{1BAF0093-92F9-460D-89B3-B0D0557B717C}"/>
+                <a16:creationId xmlns:a16="http://schemas.microsoft.com/office/drawing/2014/main" id="{C33F9C78-234B-4086-AF1A-1D30CB8F11D2}"/>
               </a:ext>
             </a:extLst>
           </p:cNvPr>
@@ -14527,7 +14380,7 @@
           <p:cNvPr id="11" name="Chart">
             <a:extLst xmlns:a="http://schemas.openxmlformats.org/drawingml/2006/main">
               <a:ext uri="{FF2B5EF4-FFF2-40B4-BE49-F238E27FC236}">
-                <a16:creationId xmlns:a16="http://schemas.microsoft.com/office/drawing/2014/main" id="{D35E1179-49D8-491E-ACA6-0DA27B22A3D5}"/>
+                <a16:creationId xmlns:a16="http://schemas.microsoft.com/office/drawing/2014/main" id="{BC1B6458-AC22-490E-951B-E0F192710BA6}"/>
               </a:ext>
             </a:extLst>
           </p:cNvPr>
@@ -14540,7 +14393,7 @@
         </p:xfrm>
         <a:graphic xmlns:a="http://schemas.openxmlformats.org/drawingml/2006/main">
           <a:graphicData uri="http://schemas.openxmlformats.org/drawingml/2006/chart">
-            <c:chart xmlns:r="http://schemas.openxmlformats.org/officeDocument/2006/relationships" xmlns:c="http://schemas.openxmlformats.org/drawingml/2006/chart" r:id="Ra8b222ccd32549a0"/>
+            <c:chart xmlns:r="http://schemas.openxmlformats.org/officeDocument/2006/relationships" xmlns:c="http://schemas.openxmlformats.org/drawingml/2006/chart" r:id="R6a5fb35618644d0d"/>
           </a:graphicData>
         </a:graphic>
       </p:graphicFrame>
@@ -14549,7 +14402,7 @@
           <p:cNvPr id="12" name="">
             <a:extLst xmlns:a="http://schemas.openxmlformats.org/drawingml/2006/main">
               <a:ext uri="{FF2B5EF4-FFF2-40B4-BE49-F238E27FC236}">
-                <a16:creationId xmlns:a16="http://schemas.microsoft.com/office/drawing/2014/main" id="{820850A5-391F-436B-BE3E-7FF4F9DF32FF}"/>
+                <a16:creationId xmlns:a16="http://schemas.microsoft.com/office/drawing/2014/main" id="{6DCF0A7C-443D-4FB9-9719-E99244199103}"/>
               </a:ext>
             </a:extLst>
           </p:cNvPr>
@@ -14638,7 +14491,7 @@
           <p:cNvPr id="13" name="">
             <a:extLst xmlns:a="http://schemas.openxmlformats.org/drawingml/2006/main">
               <a:ext uri="{FF2B5EF4-FFF2-40B4-BE49-F238E27FC236}">
-                <a16:creationId xmlns:a16="http://schemas.microsoft.com/office/drawing/2014/main" id="{4ACBC68C-E85C-4E28-A4AA-9A2256034F5C}"/>
+                <a16:creationId xmlns:a16="http://schemas.microsoft.com/office/drawing/2014/main" id="{914AEC29-7B2A-4A2B-9F38-DAFCB008C9AD}"/>
               </a:ext>
             </a:extLst>
           </p:cNvPr>
@@ -14702,7 +14555,7 @@
     </p:spTree>
     <p:extLst>
       <p:ext uri="{BB962C8B-B14F-4D97-AF65-F5344CB8AC3E}">
-        <p14:creationId xmlns:p14="http://schemas.microsoft.com/office/powerpoint/2010/main" val="408857870"/>
+        <p14:creationId xmlns:p14="http://schemas.microsoft.com/office/powerpoint/2010/main" val="943345366"/>
       </p:ext>
     </p:extLst>
   </p:cSld>

</xml_diff>